<commit_message>
resnet introduce in presentation
</commit_message>
<xml_diff>
--- a/presentation.pptx
+++ b/presentation.pptx
@@ -5,7 +5,7 @@
     <p:sldMasterId id="2147483648" r:id="rId1"/>
   </p:sldMasterIdLst>
   <p:notesMasterIdLst>
-    <p:notesMasterId r:id="rId18"/>
+    <p:notesMasterId r:id="rId20"/>
   </p:notesMasterIdLst>
   <p:sldIdLst>
     <p:sldId id="256" r:id="rId2"/>
@@ -21,9 +21,11 @@
     <p:sldId id="266" r:id="rId12"/>
     <p:sldId id="267" r:id="rId13"/>
     <p:sldId id="268" r:id="rId14"/>
-    <p:sldId id="269" r:id="rId15"/>
-    <p:sldId id="270" r:id="rId16"/>
-    <p:sldId id="271" r:id="rId17"/>
+    <p:sldId id="272" r:id="rId15"/>
+    <p:sldId id="269" r:id="rId16"/>
+    <p:sldId id="270" r:id="rId17"/>
+    <p:sldId id="273" r:id="rId18"/>
+    <p:sldId id="271" r:id="rId19"/>
   </p:sldIdLst>
   <p:sldSz cx="12192000" cy="6858000"/>
   <p:notesSz cx="6858000" cy="9144000"/>
@@ -310,17 +312,7 @@
           <a:bodyPr/>
           <a:lstStyle/>
           <a:p>
-            <a:r>
-              <a:t>Good morning/afternoon everyone. Our project investigates a simple but powerful idea: can we do accurate image classification with very few labelled examples, using only frozen self-supervised backbones and a k-nearest-neighbour classifier — with zero fine-tuning and zero learnable parameters?</a:t>
-            </a:r>
-          </a:p>
-          <a:p>
-            <a:endParaRPr/>
-          </a:p>
-          <a:p>
-            <a:r>
-              <a:t>My name is Kostis Matzaridis, and I'll be presenting alongside Contributor B and Contributor C.</a:t>
-            </a:r>
+            <a:endParaRPr dirty="0"/>
           </a:p>
         </p:txBody>
       </p:sp>
@@ -388,17 +380,7 @@
           <a:bodyPr/>
           <a:lstStyle/>
           <a:p>
-            <a:r>
-              <a:t>CIFAR-100 is 10 times harder — 100 fine-grained classes with only 500 training images each. Yet DINOv2 achieves 80.6% at 100 shots. Importantly, the model ranking is perfectly preserved across both datasets: DINOv2-reg ≈ DINOv2 &gt; DINOv1 &gt;&gt; MoCo v3.</a:t>
-            </a:r>
-          </a:p>
-          <a:p>
-            <a:endParaRPr/>
-          </a:p>
-          <a:p>
-            <a:r>
-              <a:t>I'll now pass to Speaker C for the analysis.</a:t>
-            </a:r>
+            <a:endParaRPr dirty="0"/>
           </a:p>
         </p:txBody>
       </p:sp>
@@ -466,33 +448,7 @@
           <a:bodyPr/>
           <a:lstStyle/>
           <a:p>
-            <a:r>
-              <a:t>Thank you Speaker B. Let me dig into what drives these differences, starting with the pooling strategy.</a:t>
-            </a:r>
-          </a:p>
-          <a:p>
-            <a:endParaRPr/>
-          </a:p>
-          <a:p>
-            <a:r>
-              <a:t>This bar chart compares CLS token and mean-pool features at 1-shot and 100-shot for all four models. The story is dramatically different per backbone.</a:t>
-            </a:r>
-          </a:p>
-          <a:p>
-            <a:endParaRPr/>
-          </a:p>
-          <a:p>
-            <a:r>
-              <a:t>For DINO v1, CLS is far superior — 88.4% versus 64.4% on CIFAR-10, a 24 percentage point gap. This makes sense: DINOv1's training explicitly optimises the CLS token as a holistic image summary, while the patch tokens are not trained to be individually discriminative.</a:t>
-            </a:r>
-          </a:p>
-          <a:p>
-            <a:endParaRPr/>
-          </a:p>
-          <a:p>
-            <a:r>
-              <a:t>For DINOv2, the gap closes to just 2.6 percentage points, because its masked image modelling objective forces patch tokens to carry rich local semantic content. And for MoCo v3, both pooling strategies give similarly poor results — the bottleneck is the overall feature quality, not the pooling choice.</a:t>
-            </a:r>
+            <a:endParaRPr dirty="0"/>
           </a:p>
         </p:txBody>
       </p:sp>
@@ -560,17 +516,7 @@
           <a:bodyPr/>
           <a:lstStyle/>
           <a:p>
-            <a:r>
-              <a:t>This heatmap shows how k affects accuracy at 100 shots. The main takeaway is that k has a moderate but consistent effect — going from k=1 to k=20 improves accuracy by 1 to 5 percentage points.</a:t>
-            </a:r>
-          </a:p>
-          <a:p>
-            <a:endParaRPr/>
-          </a:p>
-          <a:p>
-            <a:r>
-              <a:t>DINOv2 models are remarkably robust to k — all three values give at least 93% on CIFAR-10. MoCo v3 benefits more from larger k, which makes sense: its feature space is less cleanly clustered, so majority voting helps reduce noise.</a:t>
-            </a:r>
+            <a:endParaRPr dirty="0"/>
           </a:p>
         </p:txBody>
       </p:sp>
@@ -638,9 +584,7 @@
           <a:bodyPr/>
           <a:lstStyle/>
           <a:p>
-            <a:r>
-              <a:t>To put the results in perspective: DINOv2 achieves an 85 percentage point gain over random chance on CIFAR-10 and an 82 percentage point gain on CIFAR-100 at 100 shots. Even at just 1-shot, DINOv2 with registers gains 49 points over random on the 100-class dataset — a remarkable result from a model that saw zero target-domain labels during pretraining.</a:t>
-            </a:r>
+            <a:endParaRPr dirty="0"/>
           </a:p>
         </p:txBody>
       </p:sp>
@@ -708,57 +652,7 @@
           <a:bodyPr/>
           <a:lstStyle/>
           <a:p>
-            <a:r>
-              <a:t>Let me summarise our six key findings.</a:t>
-            </a:r>
-          </a:p>
-          <a:p>
-            <a:endParaRPr/>
-          </a:p>
-          <a:p>
-            <a:r>
-              <a:t>First, pretraining objective matters more than architecture — all four models share the same ViT-Small capacity, yet accuracy spans from 44% to 95%.</a:t>
-            </a:r>
-          </a:p>
-          <a:p>
-            <a:endParaRPr/>
-          </a:p>
-          <a:p>
-            <a:r>
-              <a:t>Second, self-distillation dramatically outperforms contrastive learning for kNN-based retrieval, by over 50 percentage points.</a:t>
-            </a:r>
-          </a:p>
-          <a:p>
-            <a:endParaRPr/>
-          </a:p>
-          <a:p>
-            <a:r>
-              <a:t>Third, DINOv2 matches a fully-supervised ResNet-50 baseline using 50 times fewer labels — the most practically impactful result.</a:t>
-            </a:r>
-          </a:p>
-          <a:p>
-            <a:endParaRPr/>
-          </a:p>
-          <a:p>
-            <a:r>
-              <a:t>Fourth, register tokens provide a small but consistent boost at low shot counts, where CLS token quality matters most.</a:t>
-            </a:r>
-          </a:p>
-          <a:p>
-            <a:endParaRPr/>
-          </a:p>
-          <a:p>
-            <a:r>
-              <a:t>Fifth, all models show log-linear scaling of accuracy with N, with the steepest gains between 1 and 10 shots.</a:t>
-            </a:r>
-          </a:p>
-          <a:p>
-            <a:endParaRPr/>
-          </a:p>
-          <a:p>
-            <a:r>
-              <a:t>And sixth, the CLS-versus-mean-pool choice is model-dependent: critical for DINOv1, negligible for DINOv2.</a:t>
-            </a:r>
+            <a:endParaRPr dirty="0"/>
           </a:p>
         </p:txBody>
       </p:sp>
@@ -826,17 +720,7 @@
           <a:bodyPr/>
           <a:lstStyle/>
           <a:p>
-            <a:r>
-              <a:t>We should note some limitations. We only tested ViT-Small variants — larger models would likely improve further. iBOT and AttMask could not be evaluated due to checkpoint access issues. And CIFAR's 32×32 resolution creates a domain gap with the pretrain data.</a:t>
-            </a:r>
-          </a:p>
-          <a:p>
-            <a:endParaRPr/>
-          </a:p>
-          <a:p>
-            <a:r>
-              <a:t>For future work, we'd like to evaluate ViT-Base and ViT-Large, test on more diverse benchmarks like mini-ImageNet and CUB-200, explore feature concatenation of CLS and mean-pool, and compare kNN against linear probing.</a:t>
-            </a:r>
+            <a:endParaRPr dirty="0"/>
           </a:p>
         </p:txBody>
       </p:sp>
@@ -904,25 +788,75 @@
           <a:bodyPr/>
           <a:lstStyle/>
           <a:p>
-            <a:r>
-              <a:t>To conclude: we've shown that frozen self-supervised ViT-Small backbones, combined with a simple temperature-weighted kNN classifier, achieve 95.1% on CIFAR-10 and 82% on CIFAR-100 with only 100 labels per class — and zero gradient updates.</a:t>
-            </a:r>
-          </a:p>
-          <a:p>
-            <a:endParaRPr/>
-          </a:p>
-          <a:p>
-            <a:r>
-              <a:t>The pretraining objective, not model size, determines downstream kNN quality. Self-distillation (DINO family) produces semantically clustered features ideal for non-parametric retrieval, and modern SSL makes labelling-efficient classification practical today.</a:t>
-            </a:r>
-          </a:p>
-          <a:p>
-            <a:endParaRPr/>
-          </a:p>
-          <a:p>
-            <a:r>
-              <a:t>Thank you for your attention. We'd be happy to take any questions.</a:t>
-            </a:r>
+            <a:endParaRPr dirty="0"/>
+          </a:p>
+        </p:txBody>
+      </p:sp>
+      <p:sp>
+        <p:nvSpPr>
+          <p:cNvPr id="4" name="Slide Number Placeholder 3"/>
+          <p:cNvSpPr>
+            <a:spLocks noGrp="1"/>
+          </p:cNvSpPr>
+          <p:nvPr>
+            <p:ph type="sldNum" sz="quarter" idx="5"/>
+          </p:nvPr>
+        </p:nvSpPr>
+        <p:spPr/>
+      </p:sp>
+    </p:spTree>
+  </p:cSld>
+  <p:clrMapOvr>
+    <a:masterClrMapping/>
+  </p:clrMapOvr>
+</p:notes>
+</file>
+
+<file path=ppt/notesSlides/notesSlide17.xml><?xml version="1.0" encoding="utf-8"?>
+<p:notes xmlns:a="http://schemas.openxmlformats.org/drawingml/2006/main" xmlns:r="http://schemas.openxmlformats.org/officeDocument/2006/relationships" xmlns:p="http://schemas.openxmlformats.org/presentationml/2006/main">
+  <p:cSld>
+    <p:spTree>
+      <p:nvGrpSpPr>
+        <p:cNvPr id="1" name=""/>
+        <p:cNvGrpSpPr/>
+        <p:nvPr/>
+      </p:nvGrpSpPr>
+      <p:grpSpPr>
+        <a:xfrm>
+          <a:off x="0" y="0"/>
+          <a:ext cx="0" cy="0"/>
+          <a:chOff x="0" y="0"/>
+          <a:chExt cx="0" cy="0"/>
+        </a:xfrm>
+      </p:grpSpPr>
+      <p:sp>
+        <p:nvSpPr>
+          <p:cNvPr id="2" name="Slide Image Placeholder 1"/>
+          <p:cNvSpPr>
+            <a:spLocks noGrp="1" noRot="1" noChangeAspect="1"/>
+          </p:cNvSpPr>
+          <p:nvPr>
+            <p:ph type="sldImg" idx="2"/>
+          </p:nvPr>
+        </p:nvSpPr>
+        <p:spPr/>
+      </p:sp>
+      <p:sp>
+        <p:nvSpPr>
+          <p:cNvPr id="3" name="Notes Placeholder 2"/>
+          <p:cNvSpPr>
+            <a:spLocks noGrp="1"/>
+          </p:cNvSpPr>
+          <p:nvPr>
+            <p:ph type="body" sz="quarter" idx="3"/>
+          </p:nvPr>
+        </p:nvSpPr>
+        <p:spPr/>
+        <p:txBody>
+          <a:bodyPr/>
+          <a:lstStyle/>
+          <a:p>
+            <a:endParaRPr dirty="0"/>
           </a:p>
         </p:txBody>
       </p:sp>
@@ -990,25 +924,7 @@
           <a:bodyPr/>
           <a:lstStyle/>
           <a:p>
-            <a:r>
-              <a:t>So why does this matter? In many real-world domains — think medical imaging, satellite monitoring, or rare species classification — you often have fewer than ten labelled examples per class. Traditional deep learning simply doesn't work in this regime.</a:t>
-            </a:r>
-          </a:p>
-          <a:p>
-            <a:endParaRPr/>
-          </a:p>
-          <a:p>
-            <a:r>
-              <a:t>Self-supervised learning, or SSL, offers a way out. It trains powerful visual features from unlabelled data using pretext tasks like self-distillation or contrastive learning. The representations it produces are general-purpose — they capture visual semantics without ever seeing a label.</a:t>
-            </a:r>
-          </a:p>
-          <a:p>
-            <a:endParaRPr/>
-          </a:p>
-          <a:p>
-            <a:r>
-              <a:t>Our key question is: are these SSL features already structured well enough that a completely non-parametric classifier — specifically k-nearest neighbours — can achieve strong accuracy? Notice the two zeros highlighted here: zero learnable parameters in our classifier, and zero gradient updates on the target dataset. Everything depends on the quality of the pretrained feature space.</a:t>
-            </a:r>
+            <a:endParaRPr dirty="0"/>
           </a:p>
         </p:txBody>
       </p:sp>
@@ -1076,25 +992,7 @@
           <a:bodyPr/>
           <a:lstStyle/>
           <a:p>
-            <a:r>
-              <a:t>Here's our complete pipeline. We start with CIFAR images — small 32×32 pixel photos. These are upsampled to 224×224 on the GPU using bicubic interpolation and normalised with ImageNet statistics.</a:t>
-            </a:r>
-          </a:p>
-          <a:p>
-            <a:endParaRPr/>
-          </a:p>
-          <a:p>
-            <a:r>
-              <a:t>They then pass through a frozen Vision Transformer backbone pretrained with SSL. From the output, we extract two types of feature vectors: the CLS token — a global summary token — and the mean of all spatial patch tokens. Both are L2-normalised, so cosine similarity reduces to a simple dot product.</a:t>
-            </a:r>
-          </a:p>
-          <a:p>
-            <a:endParaRPr/>
-          </a:p>
-          <a:p>
-            <a:r>
-              <a:t>At evaluation time, we sample N labelled support images per class and classify test images by temperature-weighted k-nearest-neighbour voting. The entire pipeline has no learnable parameters — accuracy is a direct reflection of the geometric quality of the pretrained representation space.</a:t>
-            </a:r>
+            <a:endParaRPr dirty="0"/>
           </a:p>
         </p:txBody>
       </p:sp>
@@ -1162,25 +1060,7 @@
           <a:bodyPr/>
           <a:lstStyle/>
           <a:p>
-            <a:r>
-              <a:t>We evaluate four SSL backbones, all sharing the same ViT-Small architecture with approximately 22 million parameters. This is deliberate — because the architecture is identical, any performance differences are attributable purely to the pretraining objective.</a:t>
-            </a:r>
-          </a:p>
-          <a:p>
-            <a:endParaRPr/>
-          </a:p>
-          <a:p>
-            <a:r>
-              <a:t>First, DINO ViT-S/16 — the original self-distillation method trained on ImageNet-1K. Second, DINOv2 ViT-S/14 — an improved version trained on a much larger curated dataset of 142 million images, with masked image modelling added to the objective. Third, the same DINOv2 but with register tokens — four extra learnable tokens that act as 'scratch space' for attention, cleaning up artifact patterns. And fourth, MoCo v3 — a momentum-contrastive method, representing the alternative paradigm to self-distillation.</a:t>
-            </a:r>
-          </a:p>
-          <a:p>
-            <a:endParaRPr/>
-          </a:p>
-          <a:p>
-            <a:r>
-              <a:t>The key design choice here is that same capacity, different objectives — this lets us isolate which training recipe produces the best features for nearest-neighbour retrieval.</a:t>
-            </a:r>
+            <a:endParaRPr dirty="0"/>
           </a:p>
         </p:txBody>
       </p:sp>
@@ -1248,33 +1128,7 @@
           <a:bodyPr/>
           <a:lstStyle/>
           <a:p>
-            <a:r>
-              <a:t>Thank you Speaker A. Let me explain the technical details of our approach.</a:t>
-            </a:r>
-          </a:p>
-          <a:p>
-            <a:endParaRPr/>
-          </a:p>
-          <a:p>
-            <a:r>
-              <a:t>Feature extraction happens entirely on GPU for speed. We bypass the typical CPU-side PIL image processing by loading the entire dataset as a NumPy array, converting it to a float32 tensor, and doing all normalisation and resizing in batch on the GPU.</a:t>
-            </a:r>
-          </a:p>
-          <a:p>
-            <a:endParaRPr/>
-          </a:p>
-          <a:p>
-            <a:r>
-              <a:t>The classifier uses DINO-style temperature-weighted kNN. As you can see in the formula, for each test image we find its k nearest support neighbours by cosine similarity, weight each neighbour's vote by an exponential of the similarity divided by a temperature of 0.07 — this sharpens the weights so closer neighbours matter more — and predict the class with the highest total weighted vote.</a:t>
-            </a:r>
-          </a:p>
-          <a:p>
-            <a:endParaRPr/>
-          </a:p>
-          <a:p>
-            <a:r>
-              <a:t>The implementation is fully vectorised using scatter_add — no Python loops over test samples.</a:t>
-            </a:r>
+            <a:endParaRPr dirty="0"/>
           </a:p>
         </p:txBody>
       </p:sp>
@@ -1342,17 +1196,7 @@
           <a:bodyPr/>
           <a:lstStyle/>
           <a:p>
-            <a:r>
-              <a:t>Our evaluation is exhaustive. We sweep two datasets — CIFAR-10 and CIFAR-100 — across all four backbones, both pooling strategies, seven support-set sizes from 1-shot to 100-shot, three values of k, and three random seeds per configuration. That gives us exactly 1,008 evaluated conditions.</a:t>
-            </a:r>
-          </a:p>
-          <a:p>
-            <a:endParaRPr/>
-          </a:p>
-          <a:p>
-            <a:r>
-              <a:t>Every result we report is the mean across three seeds, providing reliable estimates with variance.</a:t>
-            </a:r>
+            <a:endParaRPr dirty="0"/>
           </a:p>
         </p:txBody>
       </p:sp>
@@ -1420,9 +1264,7 @@
           <a:bodyPr/>
           <a:lstStyle/>
           <a:p>
-            <a:r>
-              <a:t>Now let's look at the results.</a:t>
-            </a:r>
+            <a:endParaRPr dirty="0"/>
           </a:p>
         </p:txBody>
       </p:sp>
@@ -1490,33 +1332,7 @@
           <a:bodyPr/>
           <a:lstStyle/>
           <a:p>
-            <a:r>
-              <a:t>This is the headline plot. It shows accuracy versus number of shots per class for all four models, using CLS token pooling and k=5.</a:t>
-            </a:r>
-          </a:p>
-          <a:p>
-            <a:endParaRPr/>
-          </a:p>
-          <a:p>
-            <a:r>
-              <a:t>On CIFAR-10, the left panel, you can see DINOv2 variants — the green and purple curves — dominating at every shot count. Even with just one labelled image per class, DINOv2 with registers achieves 68% accuracy, well above the 10% random baseline. By 100 shots, both DINOv2 variants reach approximately 95% — matching a supervised ResNet-50 trained on the full 50,000-image dataset.</a:t>
-            </a:r>
-          </a:p>
-          <a:p>
-            <a:endParaRPr/>
-          </a:p>
-          <a:p>
-            <a:r>
-              <a:t>DINO v1, the blue curve, is solid but trails by about 6 percentage points. And MoCo v3, in red, lags by over 50 percentage points — it barely surpasses 44% even at 100 shots.</a:t>
-            </a:r>
-          </a:p>
-          <a:p>
-            <a:endParaRPr/>
-          </a:p>
-          <a:p>
-            <a:r>
-              <a:t>On CIFAR-100, the right panel, the same ranking holds. DINOv2 reaches about 80% at 100 shots — an 82 percentage point gain over the 1% random baseline. The shaded bands show standard deviation, which collapses to near-zero beyond 20 shots.</a:t>
-            </a:r>
+            <a:endParaRPr dirty="0"/>
           </a:p>
         </p:txBody>
       </p:sp>
@@ -1584,17 +1400,7 @@
           <a:bodyPr/>
           <a:lstStyle/>
           <a:p>
-            <a:r>
-              <a:t>Here's the detailed CIFAR-10 table. The highlighted cells show the best results per column. DINOv2 with registers leads at 1-shot, 5-shot, and 10-shot. Standard DINOv2 takes the 100-shot crown at 94.7%.</a:t>
-            </a:r>
-          </a:p>
-          <a:p>
-            <a:endParaRPr/>
-          </a:p>
-          <a:p>
-            <a:r>
-              <a:t>The critical comparison: this 95.1% accuracy at k=20 uses only 1,000 labelled images total — that's a 50× reduction compared to a fully-supervised ResNet-50 trained on the same dataset, with no performance loss.</a:t>
-            </a:r>
+            <a:endParaRPr dirty="0"/>
           </a:p>
         </p:txBody>
       </p:sp>
@@ -1797,7 +1603,7 @@
           <a:p>
             <a:fld id="{5BCAD085-E8A6-8845-BD4E-CB4CCA059FC4}" type="datetimeFigureOut">
               <a:rPr lang="en-US" smtClean="0"/>
-              <a:t>6/21/2026</a:t>
+              <a:t>6/22/2026</a:t>
             </a:fld>
             <a:endParaRPr lang="en-US"/>
           </a:p>
@@ -1965,7 +1771,7 @@
           <a:p>
             <a:fld id="{5BCAD085-E8A6-8845-BD4E-CB4CCA059FC4}" type="datetimeFigureOut">
               <a:rPr lang="en-US" smtClean="0"/>
-              <a:t>6/21/2026</a:t>
+              <a:t>6/22/2026</a:t>
             </a:fld>
             <a:endParaRPr lang="en-US"/>
           </a:p>
@@ -2143,7 +1949,7 @@
           <a:p>
             <a:fld id="{5BCAD085-E8A6-8845-BD4E-CB4CCA059FC4}" type="datetimeFigureOut">
               <a:rPr lang="en-US" smtClean="0"/>
-              <a:t>6/21/2026</a:t>
+              <a:t>6/22/2026</a:t>
             </a:fld>
             <a:endParaRPr lang="en-US"/>
           </a:p>
@@ -2311,7 +2117,7 @@
           <a:p>
             <a:fld id="{5BCAD085-E8A6-8845-BD4E-CB4CCA059FC4}" type="datetimeFigureOut">
               <a:rPr lang="en-US" smtClean="0"/>
-              <a:t>6/21/2026</a:t>
+              <a:t>6/22/2026</a:t>
             </a:fld>
             <a:endParaRPr lang="en-US"/>
           </a:p>
@@ -2556,7 +2362,7 @@
           <a:p>
             <a:fld id="{5BCAD085-E8A6-8845-BD4E-CB4CCA059FC4}" type="datetimeFigureOut">
               <a:rPr lang="en-US" smtClean="0"/>
-              <a:t>6/21/2026</a:t>
+              <a:t>6/22/2026</a:t>
             </a:fld>
             <a:endParaRPr lang="en-US"/>
           </a:p>
@@ -2841,7 +2647,7 @@
           <a:p>
             <a:fld id="{5BCAD085-E8A6-8845-BD4E-CB4CCA059FC4}" type="datetimeFigureOut">
               <a:rPr lang="en-US" smtClean="0"/>
-              <a:t>6/21/2026</a:t>
+              <a:t>6/22/2026</a:t>
             </a:fld>
             <a:endParaRPr lang="en-US"/>
           </a:p>
@@ -3260,7 +3066,7 @@
           <a:p>
             <a:fld id="{5BCAD085-E8A6-8845-BD4E-CB4CCA059FC4}" type="datetimeFigureOut">
               <a:rPr lang="en-US" smtClean="0"/>
-              <a:t>6/21/2026</a:t>
+              <a:t>6/22/2026</a:t>
             </a:fld>
             <a:endParaRPr lang="en-US"/>
           </a:p>
@@ -3377,7 +3183,7 @@
           <a:p>
             <a:fld id="{5BCAD085-E8A6-8845-BD4E-CB4CCA059FC4}" type="datetimeFigureOut">
               <a:rPr lang="en-US" smtClean="0"/>
-              <a:t>6/21/2026</a:t>
+              <a:t>6/22/2026</a:t>
             </a:fld>
             <a:endParaRPr lang="en-US"/>
           </a:p>
@@ -3472,7 +3278,7 @@
           <a:p>
             <a:fld id="{5BCAD085-E8A6-8845-BD4E-CB4CCA059FC4}" type="datetimeFigureOut">
               <a:rPr lang="en-US" smtClean="0"/>
-              <a:t>6/21/2026</a:t>
+              <a:t>6/22/2026</a:t>
             </a:fld>
             <a:endParaRPr lang="en-US"/>
           </a:p>
@@ -3747,7 +3553,7 @@
           <a:p>
             <a:fld id="{5BCAD085-E8A6-8845-BD4E-CB4CCA059FC4}" type="datetimeFigureOut">
               <a:rPr lang="en-US" smtClean="0"/>
-              <a:t>6/21/2026</a:t>
+              <a:t>6/22/2026</a:t>
             </a:fld>
             <a:endParaRPr lang="en-US"/>
           </a:p>
@@ -3999,7 +3805,7 @@
           <a:p>
             <a:fld id="{5BCAD085-E8A6-8845-BD4E-CB4CCA059FC4}" type="datetimeFigureOut">
               <a:rPr lang="en-US" smtClean="0"/>
-              <a:t>6/21/2026</a:t>
+              <a:t>6/22/2026</a:t>
             </a:fld>
             <a:endParaRPr lang="en-US"/>
           </a:p>
@@ -4210,7 +4016,7 @@
           <a:p>
             <a:fld id="{5BCAD085-E8A6-8845-BD4E-CB4CCA059FC4}" type="datetimeFigureOut">
               <a:rPr lang="en-US" smtClean="0"/>
-              <a:t>6/21/2026</a:t>
+              <a:t>6/22/2026</a:t>
             </a:fld>
             <a:endParaRPr lang="en-US"/>
           </a:p>
@@ -4628,8 +4434,13 @@
             </a:r>
             <a:br/>
             <a:r>
-              <a:t>with Self-Supervised Backbones &amp; kNN</a:t>
-            </a:r>
+              <a:t>with Self-Supervised Backbones &amp; </a:t>
+            </a:r>
+            <a:r>
+              <a:rPr dirty="0" err="1"/>
+              <a:t>kNN</a:t>
+            </a:r>
+            <a:endParaRPr dirty="0"/>
           </a:p>
           <a:p>
             <a:pPr algn="ctr">
@@ -4644,6 +4455,7 @@
               </a:defRPr>
             </a:pPr>
             <a:r>
+              <a:rPr dirty="0"/>
               <a:t>Can frozen SSL representations enable competitive classification without any fine-tuning?</a:t>
             </a:r>
           </a:p>
@@ -6118,7 +5930,7 @@
         <p:spPr>
           <a:xfrm>
             <a:off x="6629400" y="1737360"/>
-            <a:ext cx="4663440" cy="1005840"/>
+            <a:ext cx="4663440" cy="682238"/>
           </a:xfrm>
           <a:prstGeom prst="rect">
             <a:avLst/>
@@ -6140,6 +5952,7 @@
               </a:defRPr>
             </a:pPr>
             <a:r>
+              <a:rPr dirty="0"/>
               <a:t>DINOv1: CLS wins big</a:t>
             </a:r>
           </a:p>
@@ -6156,7 +5969,24 @@
               </a:defRPr>
             </a:pPr>
             <a:r>
-              <a:t>88.4% (CLS) vs 64.4% (Mean) — 24pp gap. CLS is explicitly optimised during pretraining.</a:t>
+              <a:rPr dirty="0"/>
+              <a:t>88.4% (CLS) vs 64.4% (Mean)</a:t>
+            </a:r>
+            <a:r>
+              <a:rPr lang="en-US" dirty="0"/>
+              <a:t>:</a:t>
+            </a:r>
+            <a:r>
+              <a:rPr dirty="0"/>
+              <a:t> 24pp gap. CLS is explicitly </a:t>
+            </a:r>
+            <a:r>
+              <a:rPr dirty="0" err="1"/>
+              <a:t>optimised</a:t>
+            </a:r>
+            <a:r>
+              <a:rPr dirty="0"/>
+              <a:t> during pretraining.</a:t>
             </a:r>
           </a:p>
         </p:txBody>
@@ -6216,7 +6046,7 @@
         <p:spPr>
           <a:xfrm>
             <a:off x="6629400" y="3108960"/>
-            <a:ext cx="4663440" cy="1005840"/>
+            <a:ext cx="4663440" cy="682238"/>
           </a:xfrm>
           <a:prstGeom prst="rect">
             <a:avLst/>
@@ -6238,6 +6068,7 @@
               </a:defRPr>
             </a:pPr>
             <a:r>
+              <a:rPr dirty="0"/>
               <a:t>DINOv2: Gap closes</a:t>
             </a:r>
           </a:p>
@@ -6254,7 +6085,16 @@
               </a:defRPr>
             </a:pPr>
             <a:r>
-              <a:t>94.7% (CLS) vs 92.1% (Mean) — 2.6pp gap. MIM trains individual patch tokens to carry semantic content.</a:t>
+              <a:rPr dirty="0"/>
+              <a:t>94.7% (CLS) vs 92.1% (Mean)</a:t>
+            </a:r>
+            <a:r>
+              <a:rPr lang="en-US" dirty="0"/>
+              <a:t>:</a:t>
+            </a:r>
+            <a:r>
+              <a:rPr dirty="0"/>
+              <a:t> 2.6pp gap. MIM trains individual patch tokens to carry semantic content.</a:t>
             </a:r>
           </a:p>
         </p:txBody>
@@ -6893,6 +6733,1271 @@
 <file path=ppt/slides/slide14.xml><?xml version="1.0" encoding="utf-8"?>
 <p:sld xmlns:a="http://schemas.openxmlformats.org/drawingml/2006/main" xmlns:r="http://schemas.openxmlformats.org/officeDocument/2006/relationships" xmlns:p="http://schemas.openxmlformats.org/presentationml/2006/main">
   <p:cSld>
+    <p:spTree>
+      <p:nvGrpSpPr>
+        <p:cNvPr id="1" name=""/>
+        <p:cNvGrpSpPr/>
+        <p:nvPr/>
+      </p:nvGrpSpPr>
+      <p:grpSpPr>
+        <a:xfrm>
+          <a:off x="0" y="0"/>
+          <a:ext cx="0" cy="0"/>
+          <a:chOff x="0" y="0"/>
+          <a:chExt cx="0" cy="0"/>
+        </a:xfrm>
+      </p:grpSpPr>
+      <p:sp>
+        <p:nvSpPr>
+          <p:cNvPr id="2" name="TextBox 1"/>
+          <p:cNvSpPr txBox="1"/>
+          <p:nvPr/>
+        </p:nvSpPr>
+        <p:spPr>
+          <a:xfrm>
+            <a:off x="548640" y="365760"/>
+            <a:ext cx="11094415" cy="731520"/>
+          </a:xfrm>
+          <a:prstGeom prst="rect">
+            <a:avLst/>
+          </a:prstGeom>
+          <a:noFill/>
+        </p:spPr>
+        <p:txBody>
+          <a:bodyPr wrap="square" lIns="0" tIns="0">
+            <a:spAutoFit/>
+          </a:bodyPr>
+          <a:lstStyle/>
+          <a:p>
+            <a:pPr>
+              <a:defRPr sz="2800" b="1">
+                <a:solidFill>
+                  <a:srgbClr val="1E90FF"/>
+                </a:solidFill>
+                <a:latin typeface="Segoe UI" panose="020B0502040204020203"/>
+              </a:defRPr>
+            </a:pPr>
+            <a:r>
+              <a:t>Key Findings, Mechanisms &amp; Literature</a:t>
+            </a:r>
+          </a:p>
+          <a:p>
+            <a:pPr>
+              <a:spcBef>
+                <a:spcPts val="400"/>
+              </a:spcBef>
+              <a:defRPr sz="1400">
+                <a:solidFill>
+                  <a:srgbClr val="6E6E82"/>
+                </a:solidFill>
+                <a:latin typeface="Segoe UI" panose="020B0502040204020203"/>
+              </a:defRPr>
+            </a:pPr>
+            <a:r>
+              <a:t>A consolidated view of self-supervised representation geometry and empirical benchmarks</a:t>
+            </a:r>
+          </a:p>
+        </p:txBody>
+      </p:sp>
+      <p:sp>
+        <p:nvSpPr>
+          <p:cNvPr id="3" name="Rounded Rectangle 2"/>
+          <p:cNvSpPr/>
+          <p:nvPr/>
+        </p:nvSpPr>
+        <p:spPr>
+          <a:xfrm>
+            <a:off x="548640" y="1371600"/>
+            <a:ext cx="3447288" cy="4937760"/>
+          </a:xfrm>
+          <a:prstGeom prst="roundRect">
+            <a:avLst/>
+          </a:prstGeom>
+          <a:solidFill>
+            <a:srgbClr val="F0F8FF"/>
+          </a:solidFill>
+          <a:ln w="19050">
+            <a:solidFill>
+              <a:srgbClr val="1E90FF"/>
+            </a:solidFill>
+          </a:ln>
+        </p:spPr>
+        <p:style>
+          <a:lnRef idx="1">
+            <a:schemeClr val="accent1"/>
+          </a:lnRef>
+          <a:fillRef idx="3">
+            <a:schemeClr val="accent1"/>
+          </a:fillRef>
+          <a:effectRef idx="2">
+            <a:schemeClr val="accent1"/>
+          </a:effectRef>
+          <a:fontRef idx="minor">
+            <a:schemeClr val="lt1"/>
+          </a:fontRef>
+        </p:style>
+        <p:txBody>
+          <a:bodyPr rtlCol="0" anchor="ctr"/>
+          <a:lstStyle/>
+          <a:p>
+            <a:pPr algn="ctr"/>
+            <a:endParaRPr/>
+          </a:p>
+        </p:txBody>
+      </p:sp>
+      <p:sp>
+        <p:nvSpPr>
+          <p:cNvPr id="4" name="TextBox 3"/>
+          <p:cNvSpPr txBox="1"/>
+          <p:nvPr/>
+        </p:nvSpPr>
+        <p:spPr>
+          <a:xfrm>
+            <a:off x="685800" y="1508760"/>
+            <a:ext cx="3172968" cy="3467100"/>
+          </a:xfrm>
+          <a:prstGeom prst="rect">
+            <a:avLst/>
+          </a:prstGeom>
+          <a:noFill/>
+        </p:spPr>
+        <p:txBody>
+          <a:bodyPr wrap="square" tIns="0" bIns="0">
+            <a:spAutoFit/>
+          </a:bodyPr>
+          <a:lstStyle/>
+          <a:p>
+            <a:pPr>
+              <a:spcAft>
+                <a:spcPts val="1200"/>
+              </a:spcAft>
+              <a:defRPr sz="1400" b="1">
+                <a:solidFill>
+                  <a:srgbClr val="1E90FF"/>
+                </a:solidFill>
+                <a:latin typeface="Segoe UI" panose="020B0502040204020203"/>
+              </a:defRPr>
+            </a:pPr>
+            <a:r>
+              <a:rPr lang="en-US" dirty="0"/>
+              <a:t>   </a:t>
+            </a:r>
+            <a:r>
+              <a:rPr dirty="0"/>
+              <a:t>CORE FINDINGS</a:t>
+            </a:r>
+          </a:p>
+          <a:p>
+            <a:pPr>
+              <a:lnSpc>
+                <a:spcPct val="115000"/>
+              </a:lnSpc>
+              <a:spcAft>
+                <a:spcPts val="400"/>
+              </a:spcAft>
+            </a:pPr>
+            <a:r>
+              <a:rPr sz="1100" b="1" dirty="0">
+                <a:solidFill>
+                  <a:srgbClr val="2D2D44"/>
+                </a:solidFill>
+                <a:latin typeface="Segoe UI" panose="020B0502040204020203"/>
+              </a:rPr>
+              <a:t>Key Observations:</a:t>
+            </a:r>
+          </a:p>
+          <a:p>
+            <a:pPr lvl="1">
+              <a:lnSpc>
+                <a:spcPct val="115000"/>
+              </a:lnSpc>
+              <a:spcAft>
+                <a:spcPts val="400"/>
+              </a:spcAft>
+            </a:pPr>
+            <a:r>
+              <a:rPr sz="1000" b="1" dirty="0">
+                <a:solidFill>
+                  <a:srgbClr val="2D2D44"/>
+                </a:solidFill>
+                <a:latin typeface="Segoe UI" panose="020B0502040204020203"/>
+              </a:rPr>
+              <a:t>DINOv2</a:t>
+            </a:r>
+            <a:r>
+              <a:rPr sz="1000" b="0" dirty="0">
+                <a:solidFill>
+                  <a:srgbClr val="2D2D44"/>
+                </a:solidFill>
+                <a:latin typeface="Segoe UI" panose="020B0502040204020203"/>
+              </a:rPr>
+              <a:t> achieves best performance across all shot regimes</a:t>
+            </a:r>
+          </a:p>
+          <a:p>
+            <a:pPr lvl="1">
+              <a:lnSpc>
+                <a:spcPct val="115000"/>
+              </a:lnSpc>
+              <a:spcAft>
+                <a:spcPts val="400"/>
+              </a:spcAft>
+            </a:pPr>
+            <a:r>
+              <a:rPr sz="1000" b="1" dirty="0">
+                <a:solidFill>
+                  <a:srgbClr val="2D2D44"/>
+                </a:solidFill>
+                <a:latin typeface="Segoe UI" panose="020B0502040204020203"/>
+              </a:rPr>
+              <a:t>DINOv3</a:t>
+            </a:r>
+            <a:r>
+              <a:rPr sz="1000" b="0" dirty="0">
+                <a:solidFill>
+                  <a:srgbClr val="2D2D44"/>
+                </a:solidFill>
+                <a:latin typeface="Segoe UI" panose="020B0502040204020203"/>
+              </a:rPr>
+              <a:t> improves scaling but not </a:t>
+            </a:r>
+            <a:r>
+              <a:rPr sz="1000" b="0" dirty="0" err="1">
+                <a:solidFill>
+                  <a:srgbClr val="2D2D44"/>
+                </a:solidFill>
+                <a:latin typeface="Segoe UI" panose="020B0502040204020203"/>
+              </a:rPr>
+              <a:t>kNN</a:t>
+            </a:r>
+            <a:r>
+              <a:rPr sz="1000" b="0" dirty="0">
+                <a:solidFill>
+                  <a:srgbClr val="2D2D44"/>
+                </a:solidFill>
+                <a:latin typeface="Segoe UI" panose="020B0502040204020203"/>
+              </a:rPr>
+              <a:t> geometry</a:t>
+            </a:r>
+          </a:p>
+          <a:p>
+            <a:pPr lvl="1">
+              <a:lnSpc>
+                <a:spcPct val="115000"/>
+              </a:lnSpc>
+              <a:spcAft>
+                <a:spcPts val="400"/>
+              </a:spcAft>
+            </a:pPr>
+            <a:r>
+              <a:rPr sz="1000" b="1" dirty="0">
+                <a:solidFill>
+                  <a:srgbClr val="2D2D44"/>
+                </a:solidFill>
+                <a:latin typeface="Segoe UI" panose="020B0502040204020203"/>
+              </a:rPr>
+              <a:t>Registers</a:t>
+            </a:r>
+            <a:r>
+              <a:rPr sz="1000" b="0" dirty="0">
+                <a:solidFill>
+                  <a:srgbClr val="2D2D44"/>
+                </a:solidFill>
+                <a:latin typeface="Segoe UI" panose="020B0502040204020203"/>
+              </a:rPr>
+              <a:t> improve low-shot stability (1–10 shots)</a:t>
+            </a:r>
+          </a:p>
+          <a:p>
+            <a:pPr lvl="1">
+              <a:lnSpc>
+                <a:spcPct val="115000"/>
+              </a:lnSpc>
+              <a:spcAft>
+                <a:spcPts val="400"/>
+              </a:spcAft>
+            </a:pPr>
+            <a:r>
+              <a:rPr sz="1000" b="1" dirty="0">
+                <a:solidFill>
+                  <a:srgbClr val="2D2D44"/>
+                </a:solidFill>
+                <a:latin typeface="Segoe UI" panose="020B0502040204020203"/>
+              </a:rPr>
+              <a:t>MoCo v3</a:t>
+            </a:r>
+            <a:r>
+              <a:rPr sz="1000" b="0" dirty="0">
+                <a:solidFill>
+                  <a:srgbClr val="2D2D44"/>
+                </a:solidFill>
+                <a:latin typeface="Segoe UI" panose="020B0502040204020203"/>
+              </a:rPr>
+              <a:t> underperforms on </a:t>
+            </a:r>
+            <a:r>
+              <a:rPr sz="1000" b="0" dirty="0" err="1">
+                <a:solidFill>
+                  <a:srgbClr val="2D2D44"/>
+                </a:solidFill>
+                <a:latin typeface="Segoe UI" panose="020B0502040204020203"/>
+              </a:rPr>
+              <a:t>ViT</a:t>
+            </a:r>
+            <a:r>
+              <a:rPr sz="1000" b="0" dirty="0">
+                <a:solidFill>
+                  <a:srgbClr val="2D2D44"/>
+                </a:solidFill>
+                <a:latin typeface="Segoe UI" panose="020B0502040204020203"/>
+              </a:rPr>
+              <a:t> embeddings</a:t>
+            </a:r>
+          </a:p>
+          <a:p>
+            <a:pPr lvl="1">
+              <a:lnSpc>
+                <a:spcPct val="115000"/>
+              </a:lnSpc>
+              <a:spcAft>
+                <a:spcPts val="400"/>
+              </a:spcAft>
+            </a:pPr>
+            <a:r>
+              <a:rPr sz="1000" b="1" dirty="0" err="1">
+                <a:solidFill>
+                  <a:srgbClr val="2D2D44"/>
+                </a:solidFill>
+                <a:latin typeface="Segoe UI" panose="020B0502040204020203"/>
+              </a:rPr>
+              <a:t>iBOT</a:t>
+            </a:r>
+            <a:r>
+              <a:rPr sz="1000" b="1" dirty="0">
+                <a:solidFill>
+                  <a:srgbClr val="2D2D44"/>
+                </a:solidFill>
+                <a:latin typeface="Segoe UI" panose="020B0502040204020203"/>
+              </a:rPr>
+              <a:t> / </a:t>
+            </a:r>
+            <a:r>
+              <a:rPr sz="1000" b="1" dirty="0" err="1">
+                <a:solidFill>
+                  <a:srgbClr val="2D2D44"/>
+                </a:solidFill>
+                <a:latin typeface="Segoe UI" panose="020B0502040204020203"/>
+              </a:rPr>
+              <a:t>AttMask</a:t>
+            </a:r>
+            <a:r>
+              <a:rPr sz="1000" b="0" dirty="0">
+                <a:solidFill>
+                  <a:srgbClr val="2D2D44"/>
+                </a:solidFill>
+                <a:latin typeface="Segoe UI" panose="020B0502040204020203"/>
+              </a:rPr>
+              <a:t> are strong but below DINOv2</a:t>
+            </a:r>
+          </a:p>
+          <a:p>
+            <a:pPr>
+              <a:lnSpc>
+                <a:spcPct val="115000"/>
+              </a:lnSpc>
+              <a:spcAft>
+                <a:spcPts val="400"/>
+              </a:spcAft>
+            </a:pPr>
+            <a:endParaRPr sz="1000" b="0" dirty="0">
+              <a:solidFill>
+                <a:srgbClr val="2D2D44"/>
+              </a:solidFill>
+              <a:latin typeface="Segoe UI" panose="020B0502040204020203"/>
+            </a:endParaRPr>
+          </a:p>
+          <a:p>
+            <a:pPr>
+              <a:lnSpc>
+                <a:spcPct val="115000"/>
+              </a:lnSpc>
+              <a:spcAft>
+                <a:spcPts val="400"/>
+              </a:spcAft>
+            </a:pPr>
+            <a:r>
+              <a:rPr lang="en-US" sz="1100" b="1" dirty="0">
+                <a:solidFill>
+                  <a:srgbClr val="2D2D44"/>
+                </a:solidFill>
+                <a:latin typeface="Segoe UI" panose="020B0502040204020203"/>
+              </a:rPr>
+              <a:t> </a:t>
+            </a:r>
+            <a:r>
+              <a:rPr sz="1100" b="1" dirty="0">
+                <a:solidFill>
+                  <a:srgbClr val="2D2D44"/>
+                </a:solidFill>
+                <a:latin typeface="Segoe UI" panose="020B0502040204020203"/>
+              </a:rPr>
+              <a:t> Main Insight:</a:t>
+            </a:r>
+          </a:p>
+          <a:p>
+            <a:pPr>
+              <a:lnSpc>
+                <a:spcPct val="115000"/>
+              </a:lnSpc>
+              <a:spcAft>
+                <a:spcPts val="400"/>
+              </a:spcAft>
+            </a:pPr>
+            <a:r>
+              <a:rPr sz="1100" b="0" dirty="0">
+                <a:solidFill>
+                  <a:srgbClr val="2D2D44"/>
+                </a:solidFill>
+                <a:latin typeface="Segoe UI" panose="020B0502040204020203"/>
+              </a:rPr>
+              <a:t>Performance depends more on </a:t>
+            </a:r>
+            <a:r>
+              <a:rPr sz="1100" b="1" dirty="0">
+                <a:solidFill>
+                  <a:srgbClr val="2D2D44"/>
+                </a:solidFill>
+                <a:latin typeface="Segoe UI" panose="020B0502040204020203"/>
+              </a:rPr>
+              <a:t>embedding space geometry</a:t>
+            </a:r>
+            <a:r>
+              <a:rPr sz="1100" b="0" dirty="0">
+                <a:solidFill>
+                  <a:srgbClr val="2D2D44"/>
+                </a:solidFill>
+                <a:latin typeface="Segoe UI" panose="020B0502040204020203"/>
+              </a:rPr>
+              <a:t> than model size</a:t>
+            </a:r>
+          </a:p>
+        </p:txBody>
+      </p:sp>
+      <p:sp>
+        <p:nvSpPr>
+          <p:cNvPr id="5" name="Rounded Rectangle 4"/>
+          <p:cNvSpPr/>
+          <p:nvPr/>
+        </p:nvSpPr>
+        <p:spPr>
+          <a:xfrm>
+            <a:off x="4370832" y="1371600"/>
+            <a:ext cx="3447288" cy="4937760"/>
+          </a:xfrm>
+          <a:prstGeom prst="roundRect">
+            <a:avLst/>
+          </a:prstGeom>
+          <a:solidFill>
+            <a:srgbClr val="FAF5FF"/>
+          </a:solidFill>
+          <a:ln w="19050">
+            <a:solidFill>
+              <a:srgbClr val="9370DB"/>
+            </a:solidFill>
+          </a:ln>
+        </p:spPr>
+        <p:style>
+          <a:lnRef idx="1">
+            <a:schemeClr val="accent1"/>
+          </a:lnRef>
+          <a:fillRef idx="3">
+            <a:schemeClr val="accent1"/>
+          </a:fillRef>
+          <a:effectRef idx="2">
+            <a:schemeClr val="accent1"/>
+          </a:effectRef>
+          <a:fontRef idx="minor">
+            <a:schemeClr val="lt1"/>
+          </a:fontRef>
+        </p:style>
+        <p:txBody>
+          <a:bodyPr rtlCol="0" anchor="ctr"/>
+          <a:lstStyle/>
+          <a:p>
+            <a:pPr algn="ctr"/>
+            <a:endParaRPr/>
+          </a:p>
+        </p:txBody>
+      </p:sp>
+      <p:sp>
+        <p:nvSpPr>
+          <p:cNvPr id="6" name="TextBox 5"/>
+          <p:cNvSpPr txBox="1"/>
+          <p:nvPr/>
+        </p:nvSpPr>
+        <p:spPr>
+          <a:xfrm>
+            <a:off x="4507992" y="1508760"/>
+            <a:ext cx="3172968" cy="3973830"/>
+          </a:xfrm>
+          <a:prstGeom prst="rect">
+            <a:avLst/>
+          </a:prstGeom>
+          <a:noFill/>
+        </p:spPr>
+        <p:txBody>
+          <a:bodyPr wrap="square" tIns="0" bIns="0">
+            <a:spAutoFit/>
+          </a:bodyPr>
+          <a:lstStyle/>
+          <a:p>
+            <a:pPr>
+              <a:spcAft>
+                <a:spcPts val="1200"/>
+              </a:spcAft>
+              <a:defRPr sz="1400" b="1">
+                <a:solidFill>
+                  <a:srgbClr val="9370DB"/>
+                </a:solidFill>
+                <a:latin typeface="Segoe UI" panose="020B0502040204020203"/>
+              </a:defRPr>
+            </a:pPr>
+            <a:r>
+              <a:rPr dirty="0"/>
+              <a:t>WHY (MECHANISMS)</a:t>
+            </a:r>
+          </a:p>
+          <a:p>
+            <a:pPr>
+              <a:lnSpc>
+                <a:spcPct val="110000"/>
+              </a:lnSpc>
+              <a:spcAft>
+                <a:spcPts val="300"/>
+              </a:spcAft>
+            </a:pPr>
+            <a:r>
+              <a:rPr sz="1050" b="1" dirty="0">
+                <a:solidFill>
+                  <a:srgbClr val="2D2D44"/>
+                </a:solidFill>
+                <a:latin typeface="Segoe UI" panose="020B0502040204020203"/>
+              </a:rPr>
+              <a:t>Why these results happen:</a:t>
+            </a:r>
+          </a:p>
+          <a:p>
+            <a:pPr>
+              <a:lnSpc>
+                <a:spcPct val="110000"/>
+              </a:lnSpc>
+              <a:spcAft>
+                <a:spcPts val="300"/>
+              </a:spcAft>
+            </a:pPr>
+            <a:r>
+              <a:rPr lang="en-US" sz="1050" b="0" dirty="0">
+                <a:solidFill>
+                  <a:srgbClr val="2D2D44"/>
+                </a:solidFill>
+                <a:latin typeface="Segoe UI" panose="020B0502040204020203"/>
+              </a:rPr>
+              <a:t> </a:t>
+            </a:r>
+            <a:r>
+              <a:rPr sz="1050" b="0" dirty="0">
+                <a:solidFill>
+                  <a:srgbClr val="2D2D44"/>
+                </a:solidFill>
+                <a:latin typeface="Segoe UI" panose="020B0502040204020203"/>
+              </a:rPr>
+              <a:t> </a:t>
+            </a:r>
+            <a:r>
+              <a:rPr sz="1050" b="1" dirty="0">
+                <a:solidFill>
+                  <a:srgbClr val="2D2D44"/>
+                </a:solidFill>
+                <a:latin typeface="Segoe UI" panose="020B0502040204020203"/>
+              </a:rPr>
+              <a:t>DINOv2</a:t>
+            </a:r>
+          </a:p>
+          <a:p>
+            <a:pPr lvl="2">
+              <a:lnSpc>
+                <a:spcPct val="110000"/>
+              </a:lnSpc>
+              <a:spcAft>
+                <a:spcPts val="300"/>
+              </a:spcAft>
+            </a:pPr>
+            <a:r>
+              <a:rPr sz="950" b="0" dirty="0">
+                <a:solidFill>
+                  <a:srgbClr val="2D2D44"/>
+                </a:solidFill>
+                <a:latin typeface="Segoe UI" panose="020B0502040204020203"/>
+              </a:rPr>
+              <a:t>Large-scale pretraining (LVD-142M)</a:t>
+            </a:r>
+          </a:p>
+          <a:p>
+            <a:pPr lvl="2">
+              <a:lnSpc>
+                <a:spcPct val="110000"/>
+              </a:lnSpc>
+              <a:spcAft>
+                <a:spcPts val="300"/>
+              </a:spcAft>
+            </a:pPr>
+            <a:r>
+              <a:rPr sz="950" b="0" dirty="0">
+                <a:solidFill>
+                  <a:srgbClr val="2D2D44"/>
+                </a:solidFill>
+                <a:latin typeface="Segoe UI" panose="020B0502040204020203"/>
+              </a:rPr>
+              <a:t>Strong teacher–student distillation</a:t>
+            </a:r>
+          </a:p>
+          <a:p>
+            <a:pPr lvl="2">
+              <a:lnSpc>
+                <a:spcPct val="110000"/>
+              </a:lnSpc>
+              <a:spcAft>
+                <a:spcPts val="300"/>
+              </a:spcAft>
+            </a:pPr>
+            <a:r>
+              <a:rPr sz="950" b="0" dirty="0">
+                <a:solidFill>
+                  <a:srgbClr val="2D2D44"/>
+                </a:solidFill>
+                <a:latin typeface="Segoe UI" panose="020B0502040204020203"/>
+              </a:rPr>
+              <a:t>Highly structured embedding space</a:t>
+            </a:r>
+          </a:p>
+          <a:p>
+            <a:pPr>
+              <a:lnSpc>
+                <a:spcPct val="110000"/>
+              </a:lnSpc>
+              <a:spcAft>
+                <a:spcPts val="300"/>
+              </a:spcAft>
+            </a:pPr>
+            <a:r>
+              <a:rPr lang="en-US" sz="1050" b="1" dirty="0">
+                <a:solidFill>
+                  <a:srgbClr val="2D2D44"/>
+                </a:solidFill>
+                <a:latin typeface="Segoe UI" panose="020B0502040204020203"/>
+              </a:rPr>
+              <a:t>  </a:t>
+            </a:r>
+            <a:r>
+              <a:rPr sz="1050" b="1" dirty="0">
+                <a:solidFill>
+                  <a:srgbClr val="2D2D44"/>
+                </a:solidFill>
+                <a:latin typeface="Segoe UI" panose="020B0502040204020203"/>
+              </a:rPr>
+              <a:t>Registers</a:t>
+            </a:r>
+          </a:p>
+          <a:p>
+            <a:pPr lvl="2">
+              <a:lnSpc>
+                <a:spcPct val="110000"/>
+              </a:lnSpc>
+              <a:spcAft>
+                <a:spcPts val="300"/>
+              </a:spcAft>
+            </a:pPr>
+            <a:r>
+              <a:rPr sz="950" b="0" dirty="0">
+                <a:solidFill>
+                  <a:srgbClr val="2D2D44"/>
+                </a:solidFill>
+                <a:latin typeface="Segoe UI" panose="020B0502040204020203"/>
+              </a:rPr>
+              <a:t>Extra “memory tokens” absorb artifacts</a:t>
+            </a:r>
+          </a:p>
+          <a:p>
+            <a:pPr lvl="2">
+              <a:lnSpc>
+                <a:spcPct val="110000"/>
+              </a:lnSpc>
+              <a:spcAft>
+                <a:spcPts val="300"/>
+              </a:spcAft>
+            </a:pPr>
+            <a:r>
+              <a:rPr sz="950" b="0" dirty="0">
+                <a:solidFill>
+                  <a:srgbClr val="2D2D44"/>
+                </a:solidFill>
+                <a:latin typeface="Segoe UI" panose="020B0502040204020203"/>
+              </a:rPr>
+              <a:t>Better low-shot robustness</a:t>
+            </a:r>
+          </a:p>
+          <a:p>
+            <a:pPr>
+              <a:lnSpc>
+                <a:spcPct val="110000"/>
+              </a:lnSpc>
+              <a:spcAft>
+                <a:spcPts val="300"/>
+              </a:spcAft>
+            </a:pPr>
+            <a:r>
+              <a:rPr lang="en-US" sz="1050" b="1" dirty="0">
+                <a:solidFill>
+                  <a:srgbClr val="2D2D44"/>
+                </a:solidFill>
+                <a:latin typeface="Segoe UI" panose="020B0502040204020203"/>
+              </a:rPr>
+              <a:t>  </a:t>
+            </a:r>
+            <a:r>
+              <a:rPr sz="1050" b="1" dirty="0">
+                <a:solidFill>
+                  <a:srgbClr val="2D2D44"/>
+                </a:solidFill>
+                <a:latin typeface="Segoe UI" panose="020B0502040204020203"/>
+              </a:rPr>
+              <a:t>DINOv3</a:t>
+            </a:r>
+          </a:p>
+          <a:p>
+            <a:pPr lvl="2">
+              <a:lnSpc>
+                <a:spcPct val="110000"/>
+              </a:lnSpc>
+              <a:spcAft>
+                <a:spcPts val="300"/>
+              </a:spcAft>
+            </a:pPr>
+            <a:r>
+              <a:rPr sz="950" b="0" dirty="0">
+                <a:solidFill>
+                  <a:srgbClr val="2D2D44"/>
+                </a:solidFill>
+                <a:latin typeface="Segoe UI" panose="020B0502040204020203"/>
+              </a:rPr>
+              <a:t>Extreme scaling (data + params)</a:t>
+            </a:r>
+          </a:p>
+          <a:p>
+            <a:pPr lvl="2">
+              <a:lnSpc>
+                <a:spcPct val="110000"/>
+              </a:lnSpc>
+              <a:spcAft>
+                <a:spcPts val="300"/>
+              </a:spcAft>
+            </a:pPr>
+            <a:r>
+              <a:rPr sz="950" b="0" dirty="0">
+                <a:solidFill>
+                  <a:srgbClr val="2D2D44"/>
+                </a:solidFill>
+                <a:latin typeface="Segoe UI" panose="020B0502040204020203"/>
+              </a:rPr>
+              <a:t>Optimized for generalization, not clustering</a:t>
+            </a:r>
+          </a:p>
+          <a:p>
+            <a:pPr>
+              <a:lnSpc>
+                <a:spcPct val="110000"/>
+              </a:lnSpc>
+              <a:spcAft>
+                <a:spcPts val="300"/>
+              </a:spcAft>
+            </a:pPr>
+            <a:r>
+              <a:rPr lang="en-US" sz="1050" b="1" dirty="0">
+                <a:solidFill>
+                  <a:srgbClr val="2D2D44"/>
+                </a:solidFill>
+                <a:latin typeface="Segoe UI" panose="020B0502040204020203"/>
+              </a:rPr>
+              <a:t>  </a:t>
+            </a:r>
+            <a:r>
+              <a:rPr sz="1050" b="1" dirty="0">
+                <a:solidFill>
+                  <a:srgbClr val="2D2D44"/>
+                </a:solidFill>
+                <a:latin typeface="Segoe UI" panose="020B0502040204020203"/>
+              </a:rPr>
+              <a:t>MoCo v3</a:t>
+            </a:r>
+          </a:p>
+          <a:p>
+            <a:pPr lvl="2">
+              <a:lnSpc>
+                <a:spcPct val="110000"/>
+              </a:lnSpc>
+              <a:spcAft>
+                <a:spcPts val="300"/>
+              </a:spcAft>
+            </a:pPr>
+            <a:r>
+              <a:rPr sz="950" b="0" dirty="0">
+                <a:solidFill>
+                  <a:srgbClr val="2D2D44"/>
+                </a:solidFill>
+                <a:latin typeface="Segoe UI" panose="020B0502040204020203"/>
+              </a:rPr>
+              <a:t>Contrastive learning + negatives</a:t>
+            </a:r>
+          </a:p>
+          <a:p>
+            <a:pPr lvl="2">
+              <a:lnSpc>
+                <a:spcPct val="110000"/>
+              </a:lnSpc>
+              <a:spcAft>
+                <a:spcPts val="300"/>
+              </a:spcAft>
+            </a:pPr>
+            <a:r>
+              <a:rPr sz="950" b="0" dirty="0">
+                <a:solidFill>
+                  <a:srgbClr val="2D2D44"/>
+                </a:solidFill>
+                <a:latin typeface="Segoe UI" panose="020B0502040204020203"/>
+              </a:rPr>
+              <a:t>Weaker </a:t>
+            </a:r>
+            <a:r>
+              <a:rPr sz="950" b="0" dirty="0" err="1">
+                <a:solidFill>
+                  <a:srgbClr val="2D2D44"/>
+                </a:solidFill>
+                <a:latin typeface="Segoe UI" panose="020B0502040204020203"/>
+              </a:rPr>
+              <a:t>ViT</a:t>
+            </a:r>
+            <a:r>
+              <a:rPr sz="950" b="0" dirty="0">
+                <a:solidFill>
+                  <a:srgbClr val="2D2D44"/>
+                </a:solidFill>
+                <a:latin typeface="Segoe UI" panose="020B0502040204020203"/>
+              </a:rPr>
+              <a:t> embedding geometry</a:t>
+            </a:r>
+          </a:p>
+          <a:p>
+            <a:pPr>
+              <a:lnSpc>
+                <a:spcPct val="110000"/>
+              </a:lnSpc>
+              <a:spcAft>
+                <a:spcPts val="300"/>
+              </a:spcAft>
+            </a:pPr>
+            <a:r>
+              <a:rPr lang="en-US" sz="1050" b="1" dirty="0">
+                <a:solidFill>
+                  <a:srgbClr val="2D2D44"/>
+                </a:solidFill>
+                <a:latin typeface="Segoe UI" panose="020B0502040204020203"/>
+              </a:rPr>
+              <a:t>  </a:t>
+            </a:r>
+            <a:r>
+              <a:rPr sz="1050" b="1" dirty="0" err="1">
+                <a:solidFill>
+                  <a:srgbClr val="2D2D44"/>
+                </a:solidFill>
+                <a:latin typeface="Segoe UI" panose="020B0502040204020203"/>
+              </a:rPr>
+              <a:t>iBOT</a:t>
+            </a:r>
+            <a:r>
+              <a:rPr sz="1050" b="1" dirty="0">
+                <a:solidFill>
+                  <a:srgbClr val="2D2D44"/>
+                </a:solidFill>
+                <a:latin typeface="Segoe UI" panose="020B0502040204020203"/>
+              </a:rPr>
+              <a:t> / </a:t>
+            </a:r>
+            <a:r>
+              <a:rPr sz="1050" b="1" dirty="0" err="1">
+                <a:solidFill>
+                  <a:srgbClr val="2D2D44"/>
+                </a:solidFill>
+                <a:latin typeface="Segoe UI" panose="020B0502040204020203"/>
+              </a:rPr>
+              <a:t>AttMask</a:t>
+            </a:r>
+            <a:endParaRPr sz="1050" b="1" dirty="0">
+              <a:solidFill>
+                <a:srgbClr val="2D2D44"/>
+              </a:solidFill>
+              <a:latin typeface="Segoe UI" panose="020B0502040204020203"/>
+            </a:endParaRPr>
+          </a:p>
+          <a:p>
+            <a:pPr lvl="2">
+              <a:lnSpc>
+                <a:spcPct val="110000"/>
+              </a:lnSpc>
+              <a:spcAft>
+                <a:spcPts val="300"/>
+              </a:spcAft>
+            </a:pPr>
+            <a:r>
+              <a:rPr sz="950" b="0" dirty="0">
+                <a:solidFill>
+                  <a:srgbClr val="2D2D44"/>
+                </a:solidFill>
+                <a:latin typeface="Segoe UI" panose="020B0502040204020203"/>
+              </a:rPr>
+              <a:t>Patch-level supervision</a:t>
+            </a:r>
+          </a:p>
+          <a:p>
+            <a:pPr lvl="2">
+              <a:lnSpc>
+                <a:spcPct val="110000"/>
+              </a:lnSpc>
+              <a:spcAft>
+                <a:spcPts val="300"/>
+              </a:spcAft>
+            </a:pPr>
+            <a:r>
+              <a:rPr sz="950" b="0" dirty="0">
+                <a:solidFill>
+                  <a:srgbClr val="2D2D44"/>
+                </a:solidFill>
+                <a:latin typeface="Segoe UI" panose="020B0502040204020203"/>
+              </a:rPr>
+              <a:t>Strong local, weaker global alignment</a:t>
+            </a:r>
+          </a:p>
+        </p:txBody>
+      </p:sp>
+      <p:sp>
+        <p:nvSpPr>
+          <p:cNvPr id="7" name="Rounded Rectangle 6"/>
+          <p:cNvSpPr/>
+          <p:nvPr/>
+        </p:nvSpPr>
+        <p:spPr>
+          <a:xfrm>
+            <a:off x="8193024" y="1371600"/>
+            <a:ext cx="3447288" cy="4937760"/>
+          </a:xfrm>
+          <a:prstGeom prst="roundRect">
+            <a:avLst/>
+          </a:prstGeom>
+          <a:solidFill>
+            <a:srgbClr val="F2F9F5"/>
+          </a:solidFill>
+          <a:ln w="19050">
+            <a:solidFill>
+              <a:srgbClr val="2E8B57"/>
+            </a:solidFill>
+          </a:ln>
+        </p:spPr>
+        <p:style>
+          <a:lnRef idx="1">
+            <a:schemeClr val="accent1"/>
+          </a:lnRef>
+          <a:fillRef idx="3">
+            <a:schemeClr val="accent1"/>
+          </a:fillRef>
+          <a:effectRef idx="2">
+            <a:schemeClr val="accent1"/>
+          </a:effectRef>
+          <a:fontRef idx="minor">
+            <a:schemeClr val="lt1"/>
+          </a:fontRef>
+        </p:style>
+        <p:txBody>
+          <a:bodyPr rtlCol="0" anchor="ctr"/>
+          <a:lstStyle/>
+          <a:p>
+            <a:pPr algn="ctr"/>
+            <a:endParaRPr/>
+          </a:p>
+        </p:txBody>
+      </p:sp>
+      <p:sp>
+        <p:nvSpPr>
+          <p:cNvPr id="8" name="TextBox 7"/>
+          <p:cNvSpPr txBox="1"/>
+          <p:nvPr/>
+        </p:nvSpPr>
+        <p:spPr>
+          <a:xfrm>
+            <a:off x="8330184" y="1508760"/>
+            <a:ext cx="3172968" cy="3469005"/>
+          </a:xfrm>
+          <a:prstGeom prst="rect">
+            <a:avLst/>
+          </a:prstGeom>
+          <a:noFill/>
+        </p:spPr>
+        <p:txBody>
+          <a:bodyPr wrap="square" tIns="0" bIns="0">
+            <a:spAutoFit/>
+          </a:bodyPr>
+          <a:lstStyle/>
+          <a:p>
+            <a:pPr>
+              <a:spcAft>
+                <a:spcPts val="1200"/>
+              </a:spcAft>
+              <a:defRPr sz="1400" b="1">
+                <a:solidFill>
+                  <a:srgbClr val="2E8B57"/>
+                </a:solidFill>
+                <a:latin typeface="Segoe UI" panose="020B0502040204020203"/>
+              </a:defRPr>
+            </a:pPr>
+            <a:r>
+              <a:rPr lang="en-US"/>
+              <a:t>  </a:t>
+            </a:r>
+            <a:r>
+              <a:t>LITERATURE</a:t>
+            </a:r>
+          </a:p>
+          <a:p>
+            <a:pPr>
+              <a:lnSpc>
+                <a:spcPct val="115000"/>
+              </a:lnSpc>
+              <a:spcAft>
+                <a:spcPts val="600"/>
+              </a:spcAft>
+            </a:pPr>
+            <a:r>
+              <a:rPr sz="1100" b="1">
+                <a:solidFill>
+                  <a:srgbClr val="2D2D44"/>
+                </a:solidFill>
+                <a:latin typeface="Segoe UI" panose="020B0502040204020203"/>
+              </a:rPr>
+              <a:t>Caron et al., 2021 — DINO</a:t>
+            </a:r>
+          </a:p>
+          <a:p>
+            <a:pPr lvl="1">
+              <a:spcAft>
+                <a:spcPts val="1000"/>
+              </a:spcAft>
+            </a:pPr>
+            <a:r>
+              <a:rPr sz="900" u="sng">
+                <a:solidFill>
+                  <a:srgbClr val="2E8B57"/>
+                </a:solidFill>
+                <a:latin typeface="Consolas" panose="020B0609020204030204"/>
+              </a:rPr>
+              <a:t>https://arxiv.org/abs/2104.14294</a:t>
+            </a:r>
+          </a:p>
+          <a:p>
+            <a:pPr>
+              <a:lnSpc>
+                <a:spcPct val="115000"/>
+              </a:lnSpc>
+              <a:spcAft>
+                <a:spcPts val="600"/>
+              </a:spcAft>
+            </a:pPr>
+            <a:r>
+              <a:rPr sz="1100" b="1">
+                <a:solidFill>
+                  <a:srgbClr val="2D2D44"/>
+                </a:solidFill>
+                <a:latin typeface="Segoe UI" panose="020B0502040204020203"/>
+              </a:rPr>
+              <a:t>Oquab et al., 2023 — DINOv2</a:t>
+            </a:r>
+          </a:p>
+          <a:p>
+            <a:pPr lvl="1">
+              <a:spcAft>
+                <a:spcPts val="1000"/>
+              </a:spcAft>
+            </a:pPr>
+            <a:r>
+              <a:rPr sz="900" u="sng">
+                <a:solidFill>
+                  <a:srgbClr val="2E8B57"/>
+                </a:solidFill>
+                <a:latin typeface="Consolas" panose="020B0609020204030204"/>
+              </a:rPr>
+              <a:t>https://arxiv.org/abs/2304.07193</a:t>
+            </a:r>
+          </a:p>
+          <a:p>
+            <a:pPr>
+              <a:lnSpc>
+                <a:spcPct val="115000"/>
+              </a:lnSpc>
+              <a:spcAft>
+                <a:spcPts val="600"/>
+              </a:spcAft>
+            </a:pPr>
+            <a:r>
+              <a:rPr sz="1100" b="1">
+                <a:solidFill>
+                  <a:srgbClr val="2D2D44"/>
+                </a:solidFill>
+                <a:latin typeface="Segoe UI" panose="020B0502040204020203"/>
+              </a:rPr>
+              <a:t>Touvron et al., 2023 — Registers</a:t>
+            </a:r>
+          </a:p>
+          <a:p>
+            <a:pPr lvl="1">
+              <a:spcAft>
+                <a:spcPts val="1000"/>
+              </a:spcAft>
+            </a:pPr>
+            <a:r>
+              <a:rPr sz="900" u="sng">
+                <a:solidFill>
+                  <a:srgbClr val="2E8B57"/>
+                </a:solidFill>
+                <a:latin typeface="Consolas" panose="020B0609020204030204"/>
+              </a:rPr>
+              <a:t>https://arxiv.org/abs/2309.16588</a:t>
+            </a:r>
+          </a:p>
+          <a:p>
+            <a:pPr>
+              <a:lnSpc>
+                <a:spcPct val="115000"/>
+              </a:lnSpc>
+              <a:spcAft>
+                <a:spcPts val="600"/>
+              </a:spcAft>
+            </a:pPr>
+            <a:r>
+              <a:rPr sz="1100" b="1">
+                <a:solidFill>
+                  <a:srgbClr val="2D2D44"/>
+                </a:solidFill>
+                <a:latin typeface="Segoe UI" panose="020B0502040204020203"/>
+              </a:rPr>
+              <a:t>Chen et al., 2021 — MoCo v3</a:t>
+            </a:r>
+          </a:p>
+          <a:p>
+            <a:pPr lvl="1">
+              <a:spcAft>
+                <a:spcPts val="1000"/>
+              </a:spcAft>
+            </a:pPr>
+            <a:r>
+              <a:rPr sz="900" u="sng">
+                <a:solidFill>
+                  <a:srgbClr val="2E8B57"/>
+                </a:solidFill>
+                <a:latin typeface="Consolas" panose="020B0609020204030204"/>
+              </a:rPr>
+              <a:t>https://arxiv.org/abs/2104.02057</a:t>
+            </a:r>
+          </a:p>
+          <a:p>
+            <a:pPr>
+              <a:lnSpc>
+                <a:spcPct val="115000"/>
+              </a:lnSpc>
+              <a:spcAft>
+                <a:spcPts val="600"/>
+              </a:spcAft>
+            </a:pPr>
+            <a:r>
+              <a:rPr sz="1100" b="1">
+                <a:solidFill>
+                  <a:srgbClr val="2D2D44"/>
+                </a:solidFill>
+                <a:latin typeface="Segoe UI" panose="020B0502040204020203"/>
+              </a:rPr>
+              <a:t>Zhou et al., 2021 — iBOT</a:t>
+            </a:r>
+          </a:p>
+          <a:p>
+            <a:pPr lvl="1">
+              <a:spcAft>
+                <a:spcPts val="1000"/>
+              </a:spcAft>
+            </a:pPr>
+            <a:r>
+              <a:rPr sz="900" u="sng">
+                <a:solidFill>
+                  <a:srgbClr val="2E8B57"/>
+                </a:solidFill>
+                <a:latin typeface="Consolas" panose="020B0609020204030204"/>
+              </a:rPr>
+              <a:t>https://arxiv.org/abs/2111.07832</a:t>
+            </a:r>
+          </a:p>
+          <a:p>
+            <a:pPr>
+              <a:lnSpc>
+                <a:spcPct val="115000"/>
+              </a:lnSpc>
+              <a:spcAft>
+                <a:spcPts val="600"/>
+              </a:spcAft>
+            </a:pPr>
+            <a:r>
+              <a:rPr sz="1100" b="1">
+                <a:solidFill>
+                  <a:srgbClr val="2D2D44"/>
+                </a:solidFill>
+                <a:latin typeface="Segoe UI" panose="020B0502040204020203"/>
+              </a:rPr>
+              <a:t>Li et al., 2022 — AttMask</a:t>
+            </a:r>
+          </a:p>
+          <a:p>
+            <a:pPr lvl="1">
+              <a:spcAft>
+                <a:spcPts val="1000"/>
+              </a:spcAft>
+            </a:pPr>
+            <a:r>
+              <a:rPr sz="900" u="sng">
+                <a:solidFill>
+                  <a:srgbClr val="2E8B57"/>
+                </a:solidFill>
+                <a:latin typeface="Consolas" panose="020B0609020204030204"/>
+              </a:rPr>
+              <a:t>https://arxiv.org/abs/2206.07605</a:t>
+            </a:r>
+          </a:p>
+        </p:txBody>
+      </p:sp>
+    </p:spTree>
+  </p:cSld>
+  <p:clrMapOvr>
+    <a:masterClrMapping/>
+  </p:clrMapOvr>
+</p:sld>
+</file>
+
+<file path=ppt/slides/slide15.xml><?xml version="1.0" encoding="utf-8"?>
+<p:sld xmlns:a="http://schemas.openxmlformats.org/drawingml/2006/main" xmlns:r="http://schemas.openxmlformats.org/officeDocument/2006/relationships" xmlns:p="http://schemas.openxmlformats.org/presentationml/2006/main">
+  <p:cSld>
     <p:bg>
       <p:bgPr>
         <a:solidFill>
@@ -7558,7 +8663,7 @@
 </p:sld>
 </file>
 
-<file path=ppt/slides/slide15.xml><?xml version="1.0" encoding="utf-8"?>
+<file path=ppt/slides/slide16.xml><?xml version="1.0" encoding="utf-8"?>
 <p:sld xmlns:a="http://schemas.openxmlformats.org/drawingml/2006/main" xmlns:r="http://schemas.openxmlformats.org/officeDocument/2006/relationships" xmlns:p="http://schemas.openxmlformats.org/presentationml/2006/main">
   <p:cSld>
     <p:bg>
@@ -7650,6 +8755,7 @@
               </a:defRPr>
             </a:pPr>
             <a:r>
+              <a:rPr dirty="0"/>
               <a:t>Limitations</a:t>
             </a:r>
           </a:p>
@@ -7664,7 +8770,7 @@
         <p:spPr>
           <a:xfrm>
             <a:off x="731520" y="2194560"/>
-            <a:ext cx="5029200" cy="3840480"/>
+            <a:ext cx="5029200" cy="3052054"/>
           </a:xfrm>
           <a:prstGeom prst="rect">
             <a:avLst/>
@@ -7692,13 +8798,67 @@
               </a:defRPr>
             </a:pPr>
             <a:r>
-              <a:rPr sz="1500" b="0">
-                <a:solidFill>
-                  <a:srgbClr val="2D2D44"/>
-                </a:solidFill>
-                <a:latin typeface="Segoe UI"/>
-              </a:rPr>
-              <a:t>Only ViT-Small variants evaluated — larger models (ViT-B/L) would likely improve downstream accuracy further.</a:t>
+              <a:rPr sz="1500" b="0" dirty="0">
+                <a:solidFill>
+                  <a:srgbClr val="2D2D44"/>
+                </a:solidFill>
+                <a:latin typeface="Segoe UI"/>
+              </a:rPr>
+              <a:t>Only </a:t>
+            </a:r>
+            <a:r>
+              <a:rPr sz="1500" b="0" dirty="0" err="1">
+                <a:solidFill>
+                  <a:srgbClr val="2D2D44"/>
+                </a:solidFill>
+                <a:latin typeface="Segoe UI"/>
+              </a:rPr>
+              <a:t>ViT</a:t>
+            </a:r>
+            <a:r>
+              <a:rPr sz="1500" b="0" dirty="0">
+                <a:solidFill>
+                  <a:srgbClr val="2D2D44"/>
+                </a:solidFill>
+                <a:latin typeface="Segoe UI"/>
+              </a:rPr>
+              <a:t>-Small variants evaluated </a:t>
+            </a:r>
+            <a:r>
+              <a:rPr lang="en-US" sz="1500" b="0" dirty="0">
+                <a:solidFill>
+                  <a:srgbClr val="2D2D44"/>
+                </a:solidFill>
+                <a:latin typeface="Segoe UI"/>
+              </a:rPr>
+              <a:t>and probably</a:t>
+            </a:r>
+            <a:r>
+              <a:rPr sz="1500" b="0" dirty="0">
+                <a:solidFill>
+                  <a:srgbClr val="2D2D44"/>
+                </a:solidFill>
+                <a:latin typeface="Segoe UI"/>
+              </a:rPr>
+              <a:t> larger models (</a:t>
+            </a:r>
+            <a:r>
+              <a:rPr sz="1500" b="0" dirty="0" err="1">
+                <a:solidFill>
+                  <a:srgbClr val="2D2D44"/>
+                </a:solidFill>
+                <a:latin typeface="Segoe UI"/>
+              </a:rPr>
+              <a:t>ViT</a:t>
+            </a:r>
+            <a:r>
+              <a:rPr sz="1500" b="0" dirty="0">
+                <a:solidFill>
+                  <a:srgbClr val="2D2D44"/>
+                </a:solidFill>
+                <a:latin typeface="Segoe UI"/>
+              </a:rPr>
+              <a:t>-B/L) would likely improve downstream accuracy further.</a:t>
             </a:r>
           </a:p>
           <a:p>
@@ -7717,13 +8877,31 @@
               </a:defRPr>
             </a:pPr>
             <a:r>
-              <a:rPr sz="1500" b="0">
-                <a:solidFill>
-                  <a:srgbClr val="2D2D44"/>
-                </a:solidFill>
-                <a:latin typeface="Segoe UI"/>
-              </a:rPr>
-              <a:t>Backbones differ in pretraining data (ImageNet-1K vs curated LVD-142M/1689M) — not a fully controlled comparison.</a:t>
+              <a:rPr sz="1500" b="0" dirty="0">
+                <a:solidFill>
+                  <a:srgbClr val="2D2D44"/>
+                </a:solidFill>
+                <a:latin typeface="Segoe UI"/>
+              </a:rPr>
+              <a:t>Backbones differ in pretraining data (ImageNet-1K vs curated LVD-142M/1689M) </a:t>
+            </a:r>
+            <a:r>
+              <a:rPr lang="en-US" sz="1500" b="0" dirty="0">
+                <a:solidFill>
+                  <a:srgbClr val="2D2D44"/>
+                </a:solidFill>
+                <a:latin typeface="Segoe UI"/>
+              </a:rPr>
+              <a:t>is</a:t>
+            </a:r>
+            <a:r>
+              <a:rPr sz="1500" b="0" dirty="0">
+                <a:solidFill>
+                  <a:srgbClr val="2D2D44"/>
+                </a:solidFill>
+                <a:latin typeface="Segoe UI"/>
+              </a:rPr>
+              <a:t> not a fully controlled comparison.</a:t>
             </a:r>
           </a:p>
           <a:p>
@@ -7742,13 +8920,31 @@
               </a:defRPr>
             </a:pPr>
             <a:r>
-              <a:rPr sz="1500" b="0">
-                <a:solidFill>
-                  <a:srgbClr val="2D2D44"/>
-                </a:solidFill>
-                <a:latin typeface="Segoe UI"/>
-              </a:rPr>
-              <a:t>CIFAR-10/100 images are low-resolution (32×32) — creating a domain gap with the pretraining datasets.</a:t>
+              <a:rPr sz="1500" b="0" dirty="0">
+                <a:solidFill>
+                  <a:srgbClr val="2D2D44"/>
+                </a:solidFill>
+                <a:latin typeface="Segoe UI"/>
+              </a:rPr>
+              <a:t>CIFAR-10/100 images are low-resolution (32×32) </a:t>
+            </a:r>
+            <a:r>
+              <a:rPr lang="en-US" sz="1500" b="0" dirty="0">
+                <a:solidFill>
+                  <a:srgbClr val="2D2D44"/>
+                </a:solidFill>
+                <a:latin typeface="Segoe UI"/>
+              </a:rPr>
+              <a:t>which</a:t>
+            </a:r>
+            <a:r>
+              <a:rPr sz="1500" b="0" dirty="0">
+                <a:solidFill>
+                  <a:srgbClr val="2D2D44"/>
+                </a:solidFill>
+                <a:latin typeface="Segoe UI"/>
+              </a:rPr>
+              <a:t> creating a domain gap with the pretraining datasets.</a:t>
             </a:r>
           </a:p>
           <a:p>
@@ -7767,7 +8963,7 @@
               </a:defRPr>
             </a:pPr>
             <a:r>
-              <a:rPr sz="1500" b="0">
+              <a:rPr sz="1500" b="0" dirty="0">
                 <a:solidFill>
                   <a:srgbClr val="2D2D44"/>
                 </a:solidFill>
@@ -7809,6 +9005,7 @@
               </a:defRPr>
             </a:pPr>
             <a:r>
+              <a:rPr dirty="0"/>
               <a:t>Future Work</a:t>
             </a:r>
           </a:p>
@@ -7970,7 +9167,936 @@
 </p:sld>
 </file>
 
-<file path=ppt/slides/slide16.xml><?xml version="1.0" encoding="utf-8"?>
+<file path=ppt/slides/slide17.xml><?xml version="1.0" encoding="utf-8"?>
+<p:sld xmlns:a="http://schemas.openxmlformats.org/drawingml/2006/main" xmlns:r="http://schemas.openxmlformats.org/officeDocument/2006/relationships" xmlns:p="http://schemas.openxmlformats.org/presentationml/2006/main">
+  <p:cSld>
+    <p:spTree>
+      <p:nvGrpSpPr>
+        <p:cNvPr id="1" name=""/>
+        <p:cNvGrpSpPr/>
+        <p:nvPr/>
+      </p:nvGrpSpPr>
+      <p:grpSpPr>
+        <a:xfrm>
+          <a:off x="0" y="0"/>
+          <a:ext cx="0" cy="0"/>
+          <a:chOff x="0" y="0"/>
+          <a:chExt cx="0" cy="0"/>
+        </a:xfrm>
+      </p:grpSpPr>
+      <p:sp>
+        <p:nvSpPr>
+          <p:cNvPr id="2" name="TextBox 1"/>
+          <p:cNvSpPr txBox="1"/>
+          <p:nvPr/>
+        </p:nvSpPr>
+        <p:spPr>
+          <a:xfrm>
+            <a:off x="731520" y="365760"/>
+            <a:ext cx="9144000" cy="1005840"/>
+          </a:xfrm>
+          <a:prstGeom prst="rect">
+            <a:avLst/>
+          </a:prstGeom>
+          <a:noFill/>
+        </p:spPr>
+        <p:txBody>
+          <a:bodyPr wrap="square" lIns="0" tIns="0" rIns="0" bIns="0">
+            <a:spAutoFit/>
+          </a:bodyPr>
+          <a:lstStyle/>
+          <a:p>
+            <a:pPr>
+              <a:defRPr sz="2800" b="1">
+                <a:solidFill>
+                  <a:srgbClr val="4361EE"/>
+                </a:solidFill>
+                <a:latin typeface="Segoe UI"/>
+              </a:defRPr>
+            </a:pPr>
+            <a:r>
+              <a:t>Supervised ResNet-50 Baseline (CLS, k=5)</a:t>
+            </a:r>
+          </a:p>
+        </p:txBody>
+      </p:sp>
+      <p:graphicFrame>
+        <p:nvGraphicFramePr>
+          <p:cNvPr id="4" name="Table 3"/>
+          <p:cNvGraphicFramePr>
+            <a:graphicFrameLocks noGrp="1"/>
+          </p:cNvGraphicFramePr>
+          <p:nvPr/>
+        </p:nvGraphicFramePr>
+        <p:xfrm>
+          <a:off x="731520" y="1645920"/>
+          <a:ext cx="6583680" cy="1828800"/>
+        </p:xfrm>
+        <a:graphic>
+          <a:graphicData uri="http://schemas.openxmlformats.org/drawingml/2006/table">
+            <a:tbl>
+              <a:tblPr firstRow="1" bandRow="1">
+                <a:tableStyleId>{5C22544A-7EE6-4342-B048-85BDC9FD1C3A}</a:tableStyleId>
+              </a:tblPr>
+              <a:tblGrid>
+                <a:gridCol w="2194560">
+                  <a:extLst>
+                    <a:ext uri="{9D8B030D-6E8A-4147-A177-3AD203B41FA5}">
+                      <a16:colId xmlns:a16="http://schemas.microsoft.com/office/drawing/2014/main" val="20000"/>
+                    </a:ext>
+                  </a:extLst>
+                </a:gridCol>
+                <a:gridCol w="1097280">
+                  <a:extLst>
+                    <a:ext uri="{9D8B030D-6E8A-4147-A177-3AD203B41FA5}">
+                      <a16:colId xmlns:a16="http://schemas.microsoft.com/office/drawing/2014/main" val="20001"/>
+                    </a:ext>
+                  </a:extLst>
+                </a:gridCol>
+                <a:gridCol w="1097280">
+                  <a:extLst>
+                    <a:ext uri="{9D8B030D-6E8A-4147-A177-3AD203B41FA5}">
+                      <a16:colId xmlns:a16="http://schemas.microsoft.com/office/drawing/2014/main" val="20002"/>
+                    </a:ext>
+                  </a:extLst>
+                </a:gridCol>
+                <a:gridCol w="1097280">
+                  <a:extLst>
+                    <a:ext uri="{9D8B030D-6E8A-4147-A177-3AD203B41FA5}">
+                      <a16:colId xmlns:a16="http://schemas.microsoft.com/office/drawing/2014/main" val="20003"/>
+                    </a:ext>
+                  </a:extLst>
+                </a:gridCol>
+                <a:gridCol w="1097280">
+                  <a:extLst>
+                    <a:ext uri="{9D8B030D-6E8A-4147-A177-3AD203B41FA5}">
+                      <a16:colId xmlns:a16="http://schemas.microsoft.com/office/drawing/2014/main" val="20004"/>
+                    </a:ext>
+                  </a:extLst>
+                </a:gridCol>
+              </a:tblGrid>
+              <a:tr h="365760">
+                <a:tc>
+                  <a:txBody>
+                    <a:bodyPr/>
+                    <a:lstStyle/>
+                    <a:p>
+                      <a:pPr algn="ctr">
+                        <a:defRPr sz="1200" b="1">
+                          <a:solidFill>
+                            <a:srgbClr val="FFFFFF"/>
+                          </a:solidFill>
+                          <a:latin typeface="Segoe UI"/>
+                        </a:defRPr>
+                      </a:pPr>
+                      <a:r>
+                        <a:t>Model</a:t>
+                      </a:r>
+                    </a:p>
+                  </a:txBody>
+                  <a:tcPr>
+                    <a:solidFill>
+                      <a:srgbClr val="4361EE"/>
+                    </a:solidFill>
+                  </a:tcPr>
+                </a:tc>
+                <a:tc>
+                  <a:txBody>
+                    <a:bodyPr/>
+                    <a:lstStyle/>
+                    <a:p>
+                      <a:pPr algn="ctr">
+                        <a:defRPr sz="1200" b="1">
+                          <a:solidFill>
+                            <a:srgbClr val="FFFFFF"/>
+                          </a:solidFill>
+                          <a:latin typeface="Segoe UI"/>
+                        </a:defRPr>
+                      </a:pPr>
+                      <a:r>
+                        <a:t>1-shot</a:t>
+                      </a:r>
+                    </a:p>
+                  </a:txBody>
+                  <a:tcPr>
+                    <a:solidFill>
+                      <a:srgbClr val="4361EE"/>
+                    </a:solidFill>
+                  </a:tcPr>
+                </a:tc>
+                <a:tc>
+                  <a:txBody>
+                    <a:bodyPr/>
+                    <a:lstStyle/>
+                    <a:p>
+                      <a:pPr algn="ctr">
+                        <a:defRPr sz="1200" b="1">
+                          <a:solidFill>
+                            <a:srgbClr val="FFFFFF"/>
+                          </a:solidFill>
+                          <a:latin typeface="Segoe UI"/>
+                        </a:defRPr>
+                      </a:pPr>
+                      <a:r>
+                        <a:t>5-shot</a:t>
+                      </a:r>
+                    </a:p>
+                  </a:txBody>
+                  <a:tcPr>
+                    <a:solidFill>
+                      <a:srgbClr val="4361EE"/>
+                    </a:solidFill>
+                  </a:tcPr>
+                </a:tc>
+                <a:tc>
+                  <a:txBody>
+                    <a:bodyPr/>
+                    <a:lstStyle/>
+                    <a:p>
+                      <a:pPr algn="ctr">
+                        <a:defRPr sz="1200" b="1">
+                          <a:solidFill>
+                            <a:srgbClr val="FFFFFF"/>
+                          </a:solidFill>
+                          <a:latin typeface="Segoe UI"/>
+                        </a:defRPr>
+                      </a:pPr>
+                      <a:r>
+                        <a:t>10-shot</a:t>
+                      </a:r>
+                    </a:p>
+                  </a:txBody>
+                  <a:tcPr>
+                    <a:solidFill>
+                      <a:srgbClr val="4361EE"/>
+                    </a:solidFill>
+                  </a:tcPr>
+                </a:tc>
+                <a:tc>
+                  <a:txBody>
+                    <a:bodyPr/>
+                    <a:lstStyle/>
+                    <a:p>
+                      <a:pPr algn="ctr">
+                        <a:defRPr sz="1200" b="1">
+                          <a:solidFill>
+                            <a:srgbClr val="FFFFFF"/>
+                          </a:solidFill>
+                          <a:latin typeface="Segoe UI"/>
+                        </a:defRPr>
+                      </a:pPr>
+                      <a:r>
+                        <a:t>100-shot</a:t>
+                      </a:r>
+                    </a:p>
+                  </a:txBody>
+                  <a:tcPr>
+                    <a:solidFill>
+                      <a:srgbClr val="4361EE"/>
+                    </a:solidFill>
+                  </a:tcPr>
+                </a:tc>
+                <a:extLst>
+                  <a:ext uri="{0D108BD9-81ED-4DB2-BD59-A6C34878D82A}">
+                    <a16:rowId xmlns:a16="http://schemas.microsoft.com/office/drawing/2014/main" val="10000"/>
+                  </a:ext>
+                </a:extLst>
+              </a:tr>
+              <a:tr h="365760">
+                <a:tc>
+                  <a:txBody>
+                    <a:bodyPr/>
+                    <a:lstStyle/>
+                    <a:p>
+                      <a:pPr algn="l">
+                        <a:defRPr sz="1100">
+                          <a:solidFill>
+                            <a:srgbClr val="2D2D44"/>
+                          </a:solidFill>
+                          <a:latin typeface="Segoe UI"/>
+                        </a:defRPr>
+                      </a:pPr>
+                      <a:r>
+                        <a:t>ResNet-50 · CIFAR-10</a:t>
+                      </a:r>
+                    </a:p>
+                  </a:txBody>
+                  <a:tcPr>
+                    <a:solidFill>
+                      <a:srgbClr val="F8F9FF"/>
+                    </a:solidFill>
+                  </a:tcPr>
+                </a:tc>
+                <a:tc>
+                  <a:txBody>
+                    <a:bodyPr/>
+                    <a:lstStyle/>
+                    <a:p>
+                      <a:pPr algn="ctr">
+                        <a:defRPr sz="1100">
+                          <a:solidFill>
+                            <a:srgbClr val="2D2D44"/>
+                          </a:solidFill>
+                          <a:latin typeface="Segoe UI"/>
+                        </a:defRPr>
+                      </a:pPr>
+                      <a:r>
+                        <a:rPr b="0">
+                          <a:solidFill>
+                            <a:srgbClr val="262626"/>
+                          </a:solidFill>
+                        </a:rPr>
+                        <a:t>94.4 ± 0.1</a:t>
+                      </a:r>
+                    </a:p>
+                  </a:txBody>
+                  <a:tcPr>
+                    <a:solidFill>
+                      <a:srgbClr val="F8F9FF"/>
+                    </a:solidFill>
+                  </a:tcPr>
+                </a:tc>
+                <a:tc>
+                  <a:txBody>
+                    <a:bodyPr/>
+                    <a:lstStyle/>
+                    <a:p>
+                      <a:pPr algn="ctr">
+                        <a:defRPr sz="1100">
+                          <a:solidFill>
+                            <a:srgbClr val="2D2D44"/>
+                          </a:solidFill>
+                          <a:latin typeface="Segoe UI"/>
+                        </a:defRPr>
+                      </a:pPr>
+                      <a:r>
+                        <a:rPr b="0">
+                          <a:solidFill>
+                            <a:srgbClr val="262626"/>
+                          </a:solidFill>
+                        </a:rPr>
+                        <a:t>94.6 ± 0.1</a:t>
+                      </a:r>
+                    </a:p>
+                  </a:txBody>
+                  <a:tcPr>
+                    <a:solidFill>
+                      <a:srgbClr val="F8F9FF"/>
+                    </a:solidFill>
+                  </a:tcPr>
+                </a:tc>
+                <a:tc>
+                  <a:txBody>
+                    <a:bodyPr/>
+                    <a:lstStyle/>
+                    <a:p>
+                      <a:pPr algn="ctr">
+                        <a:defRPr sz="1100">
+                          <a:solidFill>
+                            <a:srgbClr val="2D2D44"/>
+                          </a:solidFill>
+                          <a:latin typeface="Segoe UI"/>
+                        </a:defRPr>
+                      </a:pPr>
+                      <a:r>
+                        <a:rPr b="0">
+                          <a:solidFill>
+                            <a:srgbClr val="262626"/>
+                          </a:solidFill>
+                        </a:rPr>
+                        <a:t>94.6 ± 0.0</a:t>
+                      </a:r>
+                    </a:p>
+                  </a:txBody>
+                  <a:tcPr>
+                    <a:solidFill>
+                      <a:srgbClr val="F8F9FF"/>
+                    </a:solidFill>
+                  </a:tcPr>
+                </a:tc>
+                <a:tc>
+                  <a:txBody>
+                    <a:bodyPr/>
+                    <a:lstStyle/>
+                    <a:p>
+                      <a:pPr algn="ctr">
+                        <a:defRPr sz="1100">
+                          <a:solidFill>
+                            <a:srgbClr val="2D2D44"/>
+                          </a:solidFill>
+                          <a:latin typeface="Segoe UI"/>
+                        </a:defRPr>
+                      </a:pPr>
+                      <a:r>
+                        <a:rPr b="0">
+                          <a:solidFill>
+                            <a:srgbClr val="262626"/>
+                          </a:solidFill>
+                        </a:rPr>
+                        <a:t>94.6 ± 0.1</a:t>
+                      </a:r>
+                    </a:p>
+                  </a:txBody>
+                  <a:tcPr>
+                    <a:solidFill>
+                      <a:srgbClr val="F8F9FF"/>
+                    </a:solidFill>
+                  </a:tcPr>
+                </a:tc>
+                <a:extLst>
+                  <a:ext uri="{0D108BD9-81ED-4DB2-BD59-A6C34878D82A}">
+                    <a16:rowId xmlns:a16="http://schemas.microsoft.com/office/drawing/2014/main" val="10001"/>
+                  </a:ext>
+                </a:extLst>
+              </a:tr>
+              <a:tr h="365760">
+                <a:tc>
+                  <a:txBody>
+                    <a:bodyPr/>
+                    <a:lstStyle/>
+                    <a:p>
+                      <a:pPr algn="l">
+                        <a:defRPr sz="1100">
+                          <a:solidFill>
+                            <a:srgbClr val="2D2D44"/>
+                          </a:solidFill>
+                          <a:latin typeface="Segoe UI"/>
+                        </a:defRPr>
+                      </a:pPr>
+                      <a:r>
+                        <a:t>ResNet-50 · CIFAR-10 (aug)</a:t>
+                      </a:r>
+                    </a:p>
+                  </a:txBody>
+                  <a:tcPr>
+                    <a:solidFill>
+                      <a:srgbClr val="FFFFFF"/>
+                    </a:solidFill>
+                  </a:tcPr>
+                </a:tc>
+                <a:tc>
+                  <a:txBody>
+                    <a:bodyPr/>
+                    <a:lstStyle/>
+                    <a:p>
+                      <a:pPr algn="ctr">
+                        <a:defRPr sz="1100">
+                          <a:solidFill>
+                            <a:srgbClr val="2D2D44"/>
+                          </a:solidFill>
+                          <a:latin typeface="Segoe UI"/>
+                        </a:defRPr>
+                      </a:pPr>
+                      <a:r>
+                        <a:rPr b="0">
+                          <a:solidFill>
+                            <a:srgbClr val="262626"/>
+                          </a:solidFill>
+                        </a:rPr>
+                        <a:t>91.3 ± 2.7</a:t>
+                      </a:r>
+                    </a:p>
+                  </a:txBody>
+                  <a:tcPr>
+                    <a:solidFill>
+                      <a:srgbClr val="FFFFFF"/>
+                    </a:solidFill>
+                  </a:tcPr>
+                </a:tc>
+                <a:tc>
+                  <a:txBody>
+                    <a:bodyPr/>
+                    <a:lstStyle/>
+                    <a:p>
+                      <a:pPr algn="ctr">
+                        <a:defRPr sz="1100">
+                          <a:solidFill>
+                            <a:srgbClr val="2D2D44"/>
+                          </a:solidFill>
+                          <a:latin typeface="Segoe UI"/>
+                        </a:defRPr>
+                      </a:pPr>
+                      <a:r>
+                        <a:rPr b="0">
+                          <a:solidFill>
+                            <a:srgbClr val="262626"/>
+                          </a:solidFill>
+                        </a:rPr>
+                        <a:t>94.3 ± 0.3</a:t>
+                      </a:r>
+                    </a:p>
+                  </a:txBody>
+                  <a:tcPr>
+                    <a:solidFill>
+                      <a:srgbClr val="FFFFFF"/>
+                    </a:solidFill>
+                  </a:tcPr>
+                </a:tc>
+                <a:tc>
+                  <a:txBody>
+                    <a:bodyPr/>
+                    <a:lstStyle/>
+                    <a:p>
+                      <a:pPr algn="ctr">
+                        <a:defRPr sz="1100">
+                          <a:solidFill>
+                            <a:srgbClr val="2D2D44"/>
+                          </a:solidFill>
+                          <a:latin typeface="Segoe UI"/>
+                        </a:defRPr>
+                      </a:pPr>
+                      <a:r>
+                        <a:rPr b="0">
+                          <a:solidFill>
+                            <a:srgbClr val="262626"/>
+                          </a:solidFill>
+                        </a:rPr>
+                        <a:t>94.7 ± 0.1</a:t>
+                      </a:r>
+                    </a:p>
+                  </a:txBody>
+                  <a:tcPr>
+                    <a:solidFill>
+                      <a:srgbClr val="FFFFFF"/>
+                    </a:solidFill>
+                  </a:tcPr>
+                </a:tc>
+                <a:tc>
+                  <a:txBody>
+                    <a:bodyPr/>
+                    <a:lstStyle/>
+                    <a:p>
+                      <a:pPr algn="ctr">
+                        <a:defRPr sz="1100" b="1">
+                          <a:solidFill>
+                            <a:srgbClr val="F5576C"/>
+                          </a:solidFill>
+                          <a:latin typeface="Segoe UI"/>
+                        </a:defRPr>
+                      </a:pPr>
+                      <a:r>
+                        <a:rPr b="0">
+                          <a:solidFill>
+                            <a:srgbClr val="262626"/>
+                          </a:solidFill>
+                        </a:rPr>
+                        <a:t>95.2 ± 0.2</a:t>
+                      </a:r>
+                    </a:p>
+                  </a:txBody>
+                  <a:tcPr>
+                    <a:solidFill>
+                      <a:srgbClr val="FFFFFF"/>
+                    </a:solidFill>
+                  </a:tcPr>
+                </a:tc>
+                <a:extLst>
+                  <a:ext uri="{0D108BD9-81ED-4DB2-BD59-A6C34878D82A}">
+                    <a16:rowId xmlns:a16="http://schemas.microsoft.com/office/drawing/2014/main" val="10002"/>
+                  </a:ext>
+                </a:extLst>
+              </a:tr>
+              <a:tr h="365760">
+                <a:tc>
+                  <a:txBody>
+                    <a:bodyPr/>
+                    <a:lstStyle/>
+                    <a:p>
+                      <a:pPr algn="l">
+                        <a:defRPr sz="1100">
+                          <a:solidFill>
+                            <a:srgbClr val="2D2D44"/>
+                          </a:solidFill>
+                          <a:latin typeface="Segoe UI"/>
+                        </a:defRPr>
+                      </a:pPr>
+                      <a:r>
+                        <a:t>ResNet-50 · CIFAR-100</a:t>
+                      </a:r>
+                    </a:p>
+                  </a:txBody>
+                  <a:tcPr>
+                    <a:solidFill>
+                      <a:srgbClr val="F8F9FF"/>
+                    </a:solidFill>
+                  </a:tcPr>
+                </a:tc>
+                <a:tc>
+                  <a:txBody>
+                    <a:bodyPr/>
+                    <a:lstStyle/>
+                    <a:p>
+                      <a:pPr algn="ctr">
+                        <a:defRPr sz="1100" b="1">
+                          <a:solidFill>
+                            <a:srgbClr val="F5576C"/>
+                          </a:solidFill>
+                          <a:latin typeface="Segoe UI"/>
+                        </a:defRPr>
+                      </a:pPr>
+                      <a:r>
+                        <a:rPr b="0">
+                          <a:solidFill>
+                            <a:srgbClr val="262626"/>
+                          </a:solidFill>
+                        </a:rPr>
+                        <a:t>72.2 ± 0.3</a:t>
+                      </a:r>
+                    </a:p>
+                  </a:txBody>
+                  <a:tcPr>
+                    <a:solidFill>
+                      <a:srgbClr val="F8F9FF"/>
+                    </a:solidFill>
+                  </a:tcPr>
+                </a:tc>
+                <a:tc>
+                  <a:txBody>
+                    <a:bodyPr/>
+                    <a:lstStyle/>
+                    <a:p>
+                      <a:pPr algn="ctr">
+                        <a:defRPr sz="1100" b="1">
+                          <a:solidFill>
+                            <a:srgbClr val="F5576C"/>
+                          </a:solidFill>
+                          <a:latin typeface="Segoe UI"/>
+                        </a:defRPr>
+                      </a:pPr>
+                      <a:r>
+                        <a:rPr b="0">
+                          <a:solidFill>
+                            <a:srgbClr val="262626"/>
+                          </a:solidFill>
+                        </a:rPr>
+                        <a:t>75.5 ± 0.1</a:t>
+                      </a:r>
+                    </a:p>
+                  </a:txBody>
+                  <a:tcPr>
+                    <a:solidFill>
+                      <a:srgbClr val="F8F9FF"/>
+                    </a:solidFill>
+                  </a:tcPr>
+                </a:tc>
+                <a:tc>
+                  <a:txBody>
+                    <a:bodyPr/>
+                    <a:lstStyle/>
+                    <a:p>
+                      <a:pPr algn="ctr">
+                        <a:defRPr sz="1100" b="1">
+                          <a:solidFill>
+                            <a:srgbClr val="F5576C"/>
+                          </a:solidFill>
+                          <a:latin typeface="Segoe UI"/>
+                        </a:defRPr>
+                      </a:pPr>
+                      <a:r>
+                        <a:rPr b="0">
+                          <a:solidFill>
+                            <a:srgbClr val="262626"/>
+                          </a:solidFill>
+                        </a:rPr>
+                        <a:t>75.7 ± 0.1</a:t>
+                      </a:r>
+                    </a:p>
+                  </a:txBody>
+                  <a:tcPr>
+                    <a:solidFill>
+                      <a:srgbClr val="F8F9FF"/>
+                    </a:solidFill>
+                  </a:tcPr>
+                </a:tc>
+                <a:tc>
+                  <a:txBody>
+                    <a:bodyPr/>
+                    <a:lstStyle/>
+                    <a:p>
+                      <a:pPr algn="ctr">
+                        <a:defRPr sz="1100">
+                          <a:solidFill>
+                            <a:srgbClr val="2D2D44"/>
+                          </a:solidFill>
+                          <a:latin typeface="Segoe UI"/>
+                        </a:defRPr>
+                      </a:pPr>
+                      <a:r>
+                        <a:rPr b="0">
+                          <a:solidFill>
+                            <a:srgbClr val="262626"/>
+                          </a:solidFill>
+                        </a:rPr>
+                        <a:t>76.6 ± 0.1</a:t>
+                      </a:r>
+                    </a:p>
+                  </a:txBody>
+                  <a:tcPr>
+                    <a:solidFill>
+                      <a:srgbClr val="F8F9FF"/>
+                    </a:solidFill>
+                  </a:tcPr>
+                </a:tc>
+                <a:extLst>
+                  <a:ext uri="{0D108BD9-81ED-4DB2-BD59-A6C34878D82A}">
+                    <a16:rowId xmlns:a16="http://schemas.microsoft.com/office/drawing/2014/main" val="10003"/>
+                  </a:ext>
+                </a:extLst>
+              </a:tr>
+              <a:tr h="365760">
+                <a:tc>
+                  <a:txBody>
+                    <a:bodyPr/>
+                    <a:lstStyle/>
+                    <a:p>
+                      <a:pPr algn="l">
+                        <a:defRPr sz="1100">
+                          <a:solidFill>
+                            <a:srgbClr val="2D2D44"/>
+                          </a:solidFill>
+                          <a:latin typeface="Segoe UI"/>
+                        </a:defRPr>
+                      </a:pPr>
+                      <a:r>
+                        <a:t>ResNet-50 · CIFAR-100 (aug)</a:t>
+                      </a:r>
+                    </a:p>
+                  </a:txBody>
+                  <a:tcPr>
+                    <a:solidFill>
+                      <a:srgbClr val="FFFFFF"/>
+                    </a:solidFill>
+                  </a:tcPr>
+                </a:tc>
+                <a:tc>
+                  <a:txBody>
+                    <a:bodyPr/>
+                    <a:lstStyle/>
+                    <a:p>
+                      <a:pPr algn="ctr">
+                        <a:defRPr sz="1100">
+                          <a:solidFill>
+                            <a:srgbClr val="2D2D44"/>
+                          </a:solidFill>
+                          <a:latin typeface="Segoe UI"/>
+                        </a:defRPr>
+                      </a:pPr>
+                      <a:r>
+                        <a:rPr b="0">
+                          <a:solidFill>
+                            <a:srgbClr val="262626"/>
+                          </a:solidFill>
+                        </a:rPr>
+                        <a:t>59.8 ± 1.2</a:t>
+                      </a:r>
+                    </a:p>
+                  </a:txBody>
+                  <a:tcPr>
+                    <a:solidFill>
+                      <a:srgbClr val="FFFFFF"/>
+                    </a:solidFill>
+                  </a:tcPr>
+                </a:tc>
+                <a:tc>
+                  <a:txBody>
+                    <a:bodyPr/>
+                    <a:lstStyle/>
+                    <a:p>
+                      <a:pPr algn="ctr">
+                        <a:defRPr sz="1100">
+                          <a:solidFill>
+                            <a:srgbClr val="2D2D44"/>
+                          </a:solidFill>
+                          <a:latin typeface="Segoe UI"/>
+                        </a:defRPr>
+                      </a:pPr>
+                      <a:r>
+                        <a:rPr b="0">
+                          <a:solidFill>
+                            <a:srgbClr val="262626"/>
+                          </a:solidFill>
+                        </a:rPr>
+                        <a:t>70.8 ± 0.4</a:t>
+                      </a:r>
+                    </a:p>
+                  </a:txBody>
+                  <a:tcPr>
+                    <a:solidFill>
+                      <a:srgbClr val="FFFFFF"/>
+                    </a:solidFill>
+                  </a:tcPr>
+                </a:tc>
+                <a:tc>
+                  <a:txBody>
+                    <a:bodyPr/>
+                    <a:lstStyle/>
+                    <a:p>
+                      <a:pPr algn="ctr">
+                        <a:defRPr sz="1100">
+                          <a:solidFill>
+                            <a:srgbClr val="2D2D44"/>
+                          </a:solidFill>
+                          <a:latin typeface="Segoe UI"/>
+                        </a:defRPr>
+                      </a:pPr>
+                      <a:r>
+                        <a:rPr b="0">
+                          <a:solidFill>
+                            <a:srgbClr val="262626"/>
+                          </a:solidFill>
+                        </a:rPr>
+                        <a:t>72.9 ± 0.2</a:t>
+                      </a:r>
+                    </a:p>
+                  </a:txBody>
+                  <a:tcPr>
+                    <a:solidFill>
+                      <a:srgbClr val="FFFFFF"/>
+                    </a:solidFill>
+                  </a:tcPr>
+                </a:tc>
+                <a:tc>
+                  <a:txBody>
+                    <a:bodyPr/>
+                    <a:lstStyle/>
+                    <a:p>
+                      <a:pPr algn="ctr">
+                        <a:defRPr sz="1100">
+                          <a:solidFill>
+                            <a:srgbClr val="2D2D44"/>
+                          </a:solidFill>
+                          <a:latin typeface="Segoe UI"/>
+                        </a:defRPr>
+                      </a:pPr>
+                      <a:r>
+                        <a:rPr b="0">
+                          <a:solidFill>
+                            <a:srgbClr val="262626"/>
+                          </a:solidFill>
+                        </a:rPr>
+                        <a:t>76.8 ± 0.1</a:t>
+                      </a:r>
+                    </a:p>
+                  </a:txBody>
+                  <a:tcPr>
+                    <a:solidFill>
+                      <a:srgbClr val="FFFFFF"/>
+                    </a:solidFill>
+                  </a:tcPr>
+                </a:tc>
+                <a:extLst>
+                  <a:ext uri="{0D108BD9-81ED-4DB2-BD59-A6C34878D82A}">
+                    <a16:rowId xmlns:a16="http://schemas.microsoft.com/office/drawing/2014/main" val="10004"/>
+                  </a:ext>
+                </a:extLst>
+              </a:tr>
+            </a:tbl>
+          </a:graphicData>
+        </a:graphic>
+      </p:graphicFrame>
+      <p:pic>
+        <p:nvPicPr>
+          <p:cNvPr id="5" name="Picture 4" descr="cifar10_knn_5_cls.png"/>
+          <p:cNvPicPr>
+            <a:picLocks noChangeAspect="1"/>
+          </p:cNvPicPr>
+          <p:nvPr/>
+        </p:nvPicPr>
+        <p:blipFill>
+          <a:blip r:embed="rId2"/>
+          <a:stretch>
+            <a:fillRect/>
+          </a:stretch>
+        </p:blipFill>
+        <p:spPr>
+          <a:xfrm>
+            <a:off x="7589520" y="1645920"/>
+            <a:ext cx="4114800" cy="3325171"/>
+          </a:xfrm>
+          <a:prstGeom prst="rect">
+            <a:avLst/>
+          </a:prstGeom>
+        </p:spPr>
+      </p:pic>
+      <p:sp>
+        <p:nvSpPr>
+          <p:cNvPr id="6" name="TextBox 5"/>
+          <p:cNvSpPr txBox="1"/>
+          <p:nvPr/>
+        </p:nvSpPr>
+        <p:spPr>
+          <a:xfrm>
+            <a:off x="7589520" y="4846320"/>
+            <a:ext cx="3840480" cy="430887"/>
+          </a:xfrm>
+          <a:prstGeom prst="rect">
+            <a:avLst/>
+          </a:prstGeom>
+          <a:noFill/>
+        </p:spPr>
+        <p:txBody>
+          <a:bodyPr wrap="square">
+            <a:spAutoFit/>
+          </a:bodyPr>
+          <a:lstStyle/>
+          <a:p>
+            <a:r>
+              <a:rPr sz="1100" dirty="0"/>
+              <a:t>Supervised </a:t>
+            </a:r>
+            <a:r>
+              <a:rPr sz="1100" dirty="0" err="1"/>
+              <a:t>ResNet</a:t>
+            </a:r>
+            <a:r>
+              <a:rPr sz="1100" dirty="0"/>
+              <a:t> (flat top lines) ≈ best self-supervised DINOv2  which uses no labels in pretraining.</a:t>
+            </a:r>
+          </a:p>
+        </p:txBody>
+      </p:sp>
+      <p:sp>
+        <p:nvSpPr>
+          <p:cNvPr id="7" name="TextBox 6"/>
+          <p:cNvSpPr txBox="1"/>
+          <p:nvPr/>
+        </p:nvSpPr>
+        <p:spPr>
+          <a:xfrm>
+            <a:off x="731520" y="1078992"/>
+            <a:ext cx="10698480" cy="307777"/>
+          </a:xfrm>
+          <a:prstGeom prst="rect">
+            <a:avLst/>
+          </a:prstGeom>
+          <a:noFill/>
+        </p:spPr>
+        <p:txBody>
+          <a:bodyPr wrap="square">
+            <a:spAutoFit/>
+          </a:bodyPr>
+          <a:lstStyle/>
+          <a:p>
+            <a:r>
+              <a:rPr sz="1400" i="1" dirty="0">
+                <a:solidFill>
+                  <a:srgbClr val="404040"/>
+                </a:solidFill>
+              </a:rPr>
+              <a:t>The supervised ceiling  matched on CIFAR-10 and beaten on CIFAR-100 by DINOv2, with zero labels in pretraining.</a:t>
+            </a:r>
+          </a:p>
+        </p:txBody>
+      </p:sp>
+    </p:spTree>
+  </p:cSld>
+  <p:clrMapOvr>
+    <a:masterClrMapping/>
+  </p:clrMapOvr>
+</p:sld>
+</file>
+
+<file path=ppt/slides/slide18.xml><?xml version="1.0" encoding="utf-8"?>
 <p:sld xmlns:a="http://schemas.openxmlformats.org/drawingml/2006/main" xmlns:r="http://schemas.openxmlformats.org/officeDocument/2006/relationships" xmlns:p="http://schemas.openxmlformats.org/presentationml/2006/main">
   <p:cSld>
     <p:bg>
@@ -8086,7 +10212,7 @@
         <p:spPr>
           <a:xfrm>
             <a:off x="1828800" y="2011680"/>
-            <a:ext cx="8531352" cy="2926080"/>
+            <a:ext cx="8531352" cy="2162259"/>
           </a:xfrm>
           <a:prstGeom prst="rect">
             <a:avLst/>
@@ -8114,16 +10240,43 @@
               </a:defRPr>
             </a:pPr>
             <a:r>
-              <a:rPr sz="1700" b="1">
-                <a:solidFill>
-                  <a:srgbClr val="2D2D44"/>
-                </a:solidFill>
-                <a:latin typeface="Segoe UI"/>
-              </a:rPr>
-              <a:t>Frozen SSL ViT-S + kNN</a:t>
-            </a:r>
-            <a:r>
-              <a:rPr sz="1700" b="0">
+              <a:rPr sz="1700" b="1" dirty="0">
+                <a:solidFill>
+                  <a:srgbClr val="2D2D44"/>
+                </a:solidFill>
+                <a:latin typeface="Segoe UI"/>
+              </a:rPr>
+              <a:t>Frozen SSL </a:t>
+            </a:r>
+            <a:r>
+              <a:rPr sz="1700" b="1" dirty="0" err="1">
+                <a:solidFill>
+                  <a:srgbClr val="2D2D44"/>
+                </a:solidFill>
+                <a:latin typeface="Segoe UI"/>
+              </a:rPr>
+              <a:t>ViT</a:t>
+            </a:r>
+            <a:r>
+              <a:rPr sz="1700" b="1" dirty="0">
+                <a:solidFill>
+                  <a:srgbClr val="2D2D44"/>
+                </a:solidFill>
+                <a:latin typeface="Segoe UI"/>
+              </a:rPr>
+              <a:t>-S + </a:t>
+            </a:r>
+            <a:r>
+              <a:rPr sz="1700" b="1" dirty="0" err="1">
+                <a:solidFill>
+                  <a:srgbClr val="2D2D44"/>
+                </a:solidFill>
+                <a:latin typeface="Segoe UI"/>
+              </a:rPr>
+              <a:t>kNN</a:t>
+            </a:r>
+            <a:r>
+              <a:rPr sz="1700" b="0" dirty="0">
                 <a:solidFill>
                   <a:srgbClr val="2D2D44"/>
                 </a:solidFill>
@@ -8132,7 +10285,7 @@
               <a:t> achieves </a:t>
             </a:r>
             <a:r>
-              <a:rPr sz="1700" b="1">
+              <a:rPr sz="1700" b="1" dirty="0">
                 <a:solidFill>
                   <a:srgbClr val="2D2D44"/>
                 </a:solidFill>
@@ -8141,7 +10294,7 @@
               <a:t>95.1% on CIFAR-10</a:t>
             </a:r>
             <a:r>
-              <a:rPr sz="1700" b="0">
+              <a:rPr sz="1700" b="0" dirty="0">
                 <a:solidFill>
                   <a:srgbClr val="2D2D44"/>
                 </a:solidFill>
@@ -8150,7 +10303,7 @@
               <a:t> and </a:t>
             </a:r>
             <a:r>
-              <a:rPr sz="1700" b="1">
+              <a:rPr sz="1700" b="1" dirty="0">
                 <a:solidFill>
                   <a:srgbClr val="2D2D44"/>
                 </a:solidFill>
@@ -8159,7 +10312,7 @@
               <a:t>82.0% on CIFAR-100</a:t>
             </a:r>
             <a:r>
-              <a:rPr sz="1700" b="0">
+              <a:rPr sz="1700" b="0" dirty="0">
                 <a:solidFill>
                   <a:srgbClr val="2D2D44"/>
                 </a:solidFill>
@@ -8184,7 +10337,7 @@
               </a:defRPr>
             </a:pPr>
             <a:r>
-              <a:rPr sz="1700" b="0">
+              <a:rPr sz="1700" b="0" dirty="0">
                 <a:solidFill>
                   <a:srgbClr val="2D2D44"/>
                 </a:solidFill>
@@ -8193,7 +10346,7 @@
               <a:t>The </a:t>
             </a:r>
             <a:r>
-              <a:rPr sz="1700" b="1">
+              <a:rPr sz="1700" b="1" dirty="0">
                 <a:solidFill>
                   <a:srgbClr val="2D2D44"/>
                 </a:solidFill>
@@ -8202,13 +10355,67 @@
               <a:t>pretraining objective</a:t>
             </a:r>
             <a:r>
-              <a:rPr sz="1700" b="0">
-                <a:solidFill>
-                  <a:srgbClr val="2D2D44"/>
-                </a:solidFill>
-                <a:latin typeface="Segoe UI"/>
-              </a:rPr>
-              <a:t> — not model size — determines downstream kNN quality.</a:t>
+              <a:rPr sz="1700" b="0" dirty="0">
+                <a:solidFill>
+                  <a:srgbClr val="2D2D44"/>
+                </a:solidFill>
+                <a:latin typeface="Segoe UI"/>
+              </a:rPr>
+              <a:t> </a:t>
+            </a:r>
+            <a:r>
+              <a:rPr lang="en-US" sz="1700" dirty="0">
+                <a:solidFill>
+                  <a:srgbClr val="2D2D44"/>
+                </a:solidFill>
+                <a:latin typeface="Segoe UI"/>
+              </a:rPr>
+              <a:t>and</a:t>
+            </a:r>
+            <a:r>
+              <a:rPr sz="1700" b="0" dirty="0">
+                <a:solidFill>
+                  <a:srgbClr val="2D2D44"/>
+                </a:solidFill>
+                <a:latin typeface="Segoe UI"/>
+              </a:rPr>
+              <a:t> not </a:t>
+            </a:r>
+            <a:r>
+              <a:rPr lang="en-US" sz="1700" b="0" dirty="0">
+                <a:solidFill>
+                  <a:srgbClr val="2D2D44"/>
+                </a:solidFill>
+                <a:latin typeface="Segoe UI"/>
+              </a:rPr>
+              <a:t>the </a:t>
+            </a:r>
+            <a:r>
+              <a:rPr sz="1700" b="0" dirty="0">
+                <a:solidFill>
+                  <a:srgbClr val="2D2D44"/>
+                </a:solidFill>
+                <a:latin typeface="Segoe UI"/>
+              </a:rPr>
+              <a:t>model size determines downstream </a:t>
+            </a:r>
+            <a:r>
+              <a:rPr sz="1700" b="0" dirty="0" err="1">
+                <a:solidFill>
+                  <a:srgbClr val="2D2D44"/>
+                </a:solidFill>
+                <a:latin typeface="Segoe UI"/>
+              </a:rPr>
+              <a:t>kNN</a:t>
+            </a:r>
+            <a:r>
+              <a:rPr sz="1700" b="0" dirty="0">
+                <a:solidFill>
+                  <a:srgbClr val="2D2D44"/>
+                </a:solidFill>
+                <a:latin typeface="Segoe UI"/>
+              </a:rPr>
+              <a:t> quality.</a:t>
             </a:r>
           </a:p>
           <a:p>
@@ -8227,7 +10434,7 @@
               </a:defRPr>
             </a:pPr>
             <a:r>
-              <a:rPr sz="1700" b="0">
+              <a:rPr sz="1700" b="0" dirty="0">
                 <a:solidFill>
                   <a:srgbClr val="2D2D44"/>
                 </a:solidFill>
@@ -8236,7 +10443,7 @@
               <a:t>Self-distillation (DINO family) produces </a:t>
             </a:r>
             <a:r>
-              <a:rPr sz="1700" b="1">
+              <a:rPr sz="1700" b="1" dirty="0">
                 <a:solidFill>
                   <a:srgbClr val="2D2D44"/>
                 </a:solidFill>
@@ -8245,7 +10452,7 @@
               <a:t>semantically clustered</a:t>
             </a:r>
             <a:r>
-              <a:rPr sz="1700" b="0">
+              <a:rPr sz="1700" b="0" dirty="0">
                 <a:solidFill>
                   <a:srgbClr val="2D2D44"/>
                 </a:solidFill>
@@ -8270,7 +10477,7 @@
               </a:defRPr>
             </a:pPr>
             <a:r>
-              <a:rPr sz="1700" b="0">
+              <a:rPr sz="1700" b="0" dirty="0">
                 <a:solidFill>
                   <a:srgbClr val="2D2D44"/>
                 </a:solidFill>
@@ -8279,7 +10486,7 @@
               <a:t>Modern SSL makes </a:t>
             </a:r>
             <a:r>
-              <a:rPr sz="1700" b="1">
+              <a:rPr sz="1700" b="1" dirty="0">
                 <a:solidFill>
                   <a:srgbClr val="2D2D44"/>
                 </a:solidFill>
@@ -8288,7 +10495,7 @@
               <a:t>labelling-efficient classification</a:t>
             </a:r>
             <a:r>
-              <a:rPr sz="1700" b="0">
+              <a:rPr sz="1700" b="0" dirty="0">
                 <a:solidFill>
                   <a:srgbClr val="2D2D44"/>
                 </a:solidFill>
@@ -8422,7 +10629,7 @@
         <p:spPr>
           <a:xfrm>
             <a:off x="731520" y="1645920"/>
-            <a:ext cx="5669280" cy="4114800"/>
+            <a:ext cx="5669280" cy="2833533"/>
           </a:xfrm>
           <a:prstGeom prst="rect">
             <a:avLst/>
@@ -8450,7 +10657,7 @@
               </a:defRPr>
             </a:pPr>
             <a:r>
-              <a:rPr sz="1800" b="1">
+              <a:rPr sz="1800" b="1" dirty="0">
                 <a:solidFill>
                   <a:srgbClr val="2D2D44"/>
                 </a:solidFill>
@@ -8459,7 +10666,7 @@
               <a:t>Labelling is expensive:</a:t>
             </a:r>
             <a:r>
-              <a:rPr sz="1800" b="0">
+              <a:rPr sz="1800" b="0" dirty="0">
                 <a:solidFill>
                   <a:srgbClr val="2D2D44"/>
                 </a:solidFill>
@@ -8484,7 +10691,7 @@
               </a:defRPr>
             </a:pPr>
             <a:r>
-              <a:rPr sz="1800" b="1">
+              <a:rPr sz="1800" b="1" dirty="0">
                 <a:solidFill>
                   <a:srgbClr val="2D2D44"/>
                 </a:solidFill>
@@ -8493,13 +10700,31 @@
               <a:t>Self-supervised learning (SSL)</a:t>
             </a:r>
             <a:r>
-              <a:rPr sz="1800" b="0">
-                <a:solidFill>
-                  <a:srgbClr val="2D2D44"/>
-                </a:solidFill>
-                <a:latin typeface="Segoe UI"/>
-              </a:rPr>
-              <a:t> trains powerful visual features from unlabelled data alone.</a:t>
+              <a:rPr sz="1800" b="0" dirty="0">
+                <a:solidFill>
+                  <a:srgbClr val="2D2D44"/>
+                </a:solidFill>
+                <a:latin typeface="Segoe UI"/>
+              </a:rPr>
+              <a:t> trains powerful visual features from </a:t>
+            </a:r>
+            <a:r>
+              <a:rPr sz="1800" b="0" dirty="0" err="1">
+                <a:solidFill>
+                  <a:srgbClr val="2D2D44"/>
+                </a:solidFill>
+                <a:latin typeface="Segoe UI"/>
+              </a:rPr>
+              <a:t>unlabelled</a:t>
+            </a:r>
+            <a:r>
+              <a:rPr sz="1800" b="0" dirty="0">
+                <a:solidFill>
+                  <a:srgbClr val="2D2D44"/>
+                </a:solidFill>
+                <a:latin typeface="Segoe UI"/>
+              </a:rPr>
+              <a:t> data alone.</a:t>
             </a:r>
           </a:p>
           <a:p>
@@ -8518,7 +10743,7 @@
               </a:defRPr>
             </a:pPr>
             <a:r>
-              <a:rPr sz="1800" b="1">
+              <a:rPr sz="1800" b="1" dirty="0">
                 <a:solidFill>
                   <a:srgbClr val="2D2D44"/>
                 </a:solidFill>
@@ -8527,13 +10752,31 @@
               <a:t>Key question:</a:t>
             </a:r>
             <a:r>
-              <a:rPr sz="1800" b="0">
-                <a:solidFill>
-                  <a:srgbClr val="2D2D44"/>
-                </a:solidFill>
-                <a:latin typeface="Segoe UI"/>
-              </a:rPr>
-              <a:t> Can SSL features already separate classes well enough that a simple kNN classifier works — with no gradient updates?</a:t>
+              <a:rPr sz="1800" b="0" dirty="0">
+                <a:solidFill>
+                  <a:srgbClr val="2D2D44"/>
+                </a:solidFill>
+                <a:latin typeface="Segoe UI"/>
+              </a:rPr>
+              <a:t> Can SSL features already separate classes well enough that a simple </a:t>
+            </a:r>
+            <a:r>
+              <a:rPr sz="1800" b="0" dirty="0" err="1">
+                <a:solidFill>
+                  <a:srgbClr val="2D2D44"/>
+                </a:solidFill>
+                <a:latin typeface="Segoe UI"/>
+              </a:rPr>
+              <a:t>kNN</a:t>
+            </a:r>
+            <a:r>
+              <a:rPr sz="1800" b="0" dirty="0">
+                <a:solidFill>
+                  <a:srgbClr val="2D2D44"/>
+                </a:solidFill>
+                <a:latin typeface="Segoe UI"/>
+              </a:rPr>
+              <a:t> classifier works with no gradient updates?</a:t>
             </a:r>
           </a:p>
         </p:txBody>
@@ -12015,8 +14258,8 @@
         </p:nvSpPr>
         <p:spPr>
           <a:xfrm>
-            <a:off x="6675120" y="1645920"/>
-            <a:ext cx="4754880" cy="4114800"/>
+            <a:off x="6817995" y="1645920"/>
+            <a:ext cx="4754880" cy="2775055"/>
           </a:xfrm>
           <a:prstGeom prst="rect">
             <a:avLst/>
@@ -12044,7 +14287,7 @@
               </a:defRPr>
             </a:pPr>
             <a:r>
-              <a:rPr sz="1500" b="1">
+              <a:rPr sz="1500" b="1" dirty="0">
                 <a:solidFill>
                   <a:srgbClr val="2D2D44"/>
                 </a:solidFill>
@@ -12053,7 +14296,7 @@
               <a:t>DINOv2 variants dominate</a:t>
             </a:r>
             <a:r>
-              <a:rPr sz="1500" b="0">
+              <a:rPr sz="1500" b="0" dirty="0">
                 <a:solidFill>
                   <a:srgbClr val="2D2D44"/>
                 </a:solidFill>
@@ -12078,7 +14321,7 @@
               </a:defRPr>
             </a:pPr>
             <a:r>
-              <a:rPr sz="1500" b="1">
+              <a:rPr sz="1500" b="1" dirty="0">
                 <a:solidFill>
                   <a:srgbClr val="2D2D44"/>
                 </a:solidFill>
@@ -12087,13 +14330,49 @@
               <a:t>MoCo v3 lags</a:t>
             </a:r>
             <a:r>
-              <a:rPr sz="1500" b="0">
-                <a:solidFill>
-                  <a:srgbClr val="2D2D44"/>
-                </a:solidFill>
-                <a:latin typeface="Segoe UI"/>
-              </a:rPr>
-              <a:t> by 50+ percentage points — contrastive pretraining doesn't form semantic clusters suitable for kNN classification.</a:t>
+              <a:rPr sz="1500" b="0" dirty="0">
+                <a:solidFill>
+                  <a:srgbClr val="2D2D44"/>
+                </a:solidFill>
+                <a:latin typeface="Segoe UI"/>
+              </a:rPr>
+              <a:t> by 50+ percentage points</a:t>
+            </a:r>
+            <a:r>
+              <a:rPr lang="en-US" sz="1500" b="0" dirty="0">
+                <a:solidFill>
+                  <a:srgbClr val="2D2D44"/>
+                </a:solidFill>
+                <a:latin typeface="Segoe UI"/>
+              </a:rPr>
+              <a:t>,</a:t>
+            </a:r>
+            <a:r>
+              <a:rPr sz="1500" b="0" dirty="0">
+                <a:solidFill>
+                  <a:srgbClr val="2D2D44"/>
+                </a:solidFill>
+                <a:latin typeface="Segoe UI"/>
+              </a:rPr>
+              <a:t> contrastive pretraining doesn't form semantic clusters suitable for </a:t>
+            </a:r>
+            <a:r>
+              <a:rPr sz="1500" b="0" dirty="0" err="1">
+                <a:solidFill>
+                  <a:srgbClr val="2D2D44"/>
+                </a:solidFill>
+                <a:latin typeface="Segoe UI"/>
+              </a:rPr>
+              <a:t>kNN</a:t>
+            </a:r>
+            <a:r>
+              <a:rPr sz="1500" b="0" dirty="0">
+                <a:solidFill>
+                  <a:srgbClr val="2D2D44"/>
+                </a:solidFill>
+                <a:latin typeface="Segoe UI"/>
+              </a:rPr>
+              <a:t> classification.</a:t>
             </a:r>
           </a:p>
           <a:p>
@@ -12112,7 +14391,7 @@
               </a:defRPr>
             </a:pPr>
             <a:r>
-              <a:rPr sz="1500" b="1">
+              <a:rPr sz="1500" b="1" dirty="0">
                 <a:solidFill>
                   <a:srgbClr val="2D2D44"/>
                 </a:solidFill>
@@ -12121,7 +14400,7 @@
               <a:t>Log-linear scaling</a:t>
             </a:r>
             <a:r>
-              <a:rPr sz="1500" b="0">
+              <a:rPr sz="1500" b="0" dirty="0">
                 <a:solidFill>
                   <a:srgbClr val="2D2D44"/>
                 </a:solidFill>
@@ -12146,7 +14425,7 @@
               </a:defRPr>
             </a:pPr>
             <a:r>
-              <a:rPr sz="1500" b="1">
+              <a:rPr sz="1500" b="1" dirty="0">
                 <a:solidFill>
                   <a:srgbClr val="2D2D44"/>
                 </a:solidFill>
@@ -12155,7 +14434,7 @@
               <a:t>Variance collapses</a:t>
             </a:r>
             <a:r>
-              <a:rPr sz="1500" b="0">
+              <a:rPr sz="1500" b="0" dirty="0">
                 <a:solidFill>
                   <a:srgbClr val="2D2D44"/>
                 </a:solidFill>
@@ -12232,7 +14511,7 @@
         <p:spPr>
           <a:xfrm>
             <a:off x="731520" y="365760"/>
-            <a:ext cx="9144000" cy="1005840"/>
+            <a:ext cx="9144000" cy="430887"/>
           </a:xfrm>
           <a:prstGeom prst="rect">
             <a:avLst/>
@@ -12254,7 +14533,16 @@
               </a:defRPr>
             </a:pPr>
             <a:r>
-              <a:t>CIFAR-10 Results — CLS Token (k=5)</a:t>
+              <a:rPr dirty="0"/>
+              <a:t>CIFAR-10 Results</a:t>
+            </a:r>
+            <a:r>
+              <a:rPr lang="en-US" dirty="0"/>
+              <a:t>: </a:t>
+            </a:r>
+            <a:r>
+              <a:rPr dirty="0"/>
+              <a:t>CLS Token (k=5)</a:t>
             </a:r>
           </a:p>
         </p:txBody>
@@ -13560,7 +15848,7 @@
                 </a:solidFill>
                 <a:latin typeface="Segoe UI"/>
               </a:rPr>
-              <a:t> — matching a supervised ResNet-50 trained on </a:t>
+              <a:t>  matching a supervised ResNet-50 trained on </a:t>
             </a:r>
             <a:r>
               <a:rPr sz="1600" b="1" dirty="0">

</xml_diff>